<commit_message>
docs: use noto sans jp for umee deck
</commit_message>
<xml_diff>
--- a/deck-system/decks/umee-sbcs-kintone-plan/exports/umee-sbcs-kintone-plan-editable.pptx
+++ b/deck-system/decks/umee-sbcs-kintone-plan/exports/umee-sbcs-kintone-plan-editable.pptx
@@ -129,8 +129,8 @@
                 <a:solidFill>
                   <a:srgbClr val="6D7375"/>
                 </a:solidFill>
-                <a:latin typeface="Aptos"/>
-                <a:ea typeface="Yu Gothic"/>
+                <a:latin typeface="Noto Sans JP"/>
+                <a:ea typeface="Noto Sans JP"/>
               </a:rPr>
               <a:t>kintone利用企業に向けたセットプランの料金設計とGTM整理</a:t>
             </a:r>
@@ -195,8 +195,8 @@
                 <a:solidFill>
                   <a:srgbClr val="6D7375"/>
                 </a:solidFill>
-                <a:latin typeface="Aptos"/>
-                <a:ea typeface="Yu Gothic"/>
+                <a:latin typeface="Noto Sans JP"/>
+                <a:ea typeface="Noto Sans JP"/>
               </a:rPr>
               <a:t>作成日</a:t>
             </a:r>
@@ -232,8 +232,8 @@
                 <a:solidFill>
                   <a:srgbClr val="414242"/>
                 </a:solidFill>
-                <a:latin typeface="Aptos"/>
-                <a:ea typeface="Yu Gothic"/>
+                <a:latin typeface="Noto Sans JP"/>
+                <a:ea typeface="Noto Sans JP"/>
               </a:rPr>
               <a:t>2026.05.26</a:t>
             </a:r>
@@ -298,8 +298,8 @@
                 <a:solidFill>
                   <a:srgbClr val="6D7375"/>
                 </a:solidFill>
-                <a:latin typeface="Aptos"/>
-                <a:ea typeface="Yu Gothic"/>
+                <a:latin typeface="Noto Sans JP"/>
+                <a:ea typeface="Noto Sans JP"/>
               </a:rPr>
               <a:t>論点</a:t>
             </a:r>
@@ -335,8 +335,8 @@
                 <a:solidFill>
                   <a:srgbClr val="414242"/>
                 </a:solidFill>
-                <a:latin typeface="Aptos"/>
-                <a:ea typeface="Yu Gothic"/>
+                <a:latin typeface="Noto Sans JP"/>
+                <a:ea typeface="Noto Sans JP"/>
               </a:rPr>
               <a:t>価格 / ID / 比較軸 / 支援範囲 / 販売条件</a:t>
             </a:r>
@@ -401,8 +401,8 @@
                 <a:solidFill>
                   <a:srgbClr val="6D7375"/>
                 </a:solidFill>
-                <a:latin typeface="Aptos"/>
-                <a:ea typeface="Yu Gothic"/>
+                <a:latin typeface="Noto Sans JP"/>
+                <a:ea typeface="Noto Sans JP"/>
               </a:rPr>
               <a:t>SB C&amp;S 向け提案</a:t>
             </a:r>
@@ -438,8 +438,8 @@
                 <a:solidFill>
                   <a:srgbClr val="414242"/>
                 </a:solidFill>
-                <a:latin typeface="Aptos"/>
-                <a:ea typeface="Yu Gothic"/>
+                <a:latin typeface="Noto Sans JP"/>
+                <a:ea typeface="Noto Sans JP"/>
               </a:rPr>
               <a:t>FrontAgent</a:t>
             </a:r>
@@ -475,8 +475,8 @@
                 <a:solidFill>
                   <a:srgbClr val="414242"/>
                 </a:solidFill>
-                <a:latin typeface="Aptos"/>
-                <a:ea typeface="Yu Gothic"/>
+                <a:latin typeface="Noto Sans JP"/>
+                <a:ea typeface="Noto Sans JP"/>
               </a:rPr>
               <a:t>FrontAgent x kintone を、売りやすい料金体系にする</a:t>
             </a:r>
@@ -570,8 +570,8 @@
                 <a:solidFill>
                   <a:srgbClr val="6D7375"/>
                 </a:solidFill>
-                <a:latin typeface="Aptos"/>
-                <a:ea typeface="Yu Gothic"/>
+                <a:latin typeface="Noto Sans JP"/>
+                <a:ea typeface="Noto Sans JP"/>
               </a:rPr>
               <a:t>Umee Technologies</a:t>
             </a:r>
@@ -607,8 +607,8 @@
                 <a:solidFill>
                   <a:srgbClr val="6D7375"/>
                 </a:solidFill>
-                <a:latin typeface="Aptos"/>
-                <a:ea typeface="Yu Gothic"/>
+                <a:latin typeface="Noto Sans JP"/>
+                <a:ea typeface="Noto Sans JP"/>
               </a:rPr>
               <a:t>01</a:t>
             </a:r>
@@ -648,7 +648,7 @@
                 <a:solidFill>
                   <a:srgbClr val="FF7143"/>
                 </a:solidFill>
-                <a:ea typeface="Yu Gothic"/>
+                <a:ea typeface="Noto Sans JP"/>
               </a:rPr>
               <a:t/>
             </a:r>
@@ -738,8 +738,8 @@
                 <a:solidFill>
                   <a:srgbClr val="414242"/>
                 </a:solidFill>
-                <a:latin typeface="Aptos"/>
-                <a:ea typeface="Yu Gothic"/>
+                <a:latin typeface="Noto Sans JP"/>
+                <a:ea typeface="Noto Sans JP"/>
               </a:rPr>
               <a:t>区分</a:t>
             </a:r>
@@ -804,8 +804,8 @@
                 <a:solidFill>
                   <a:srgbClr val="414242"/>
                 </a:solidFill>
-                <a:latin typeface="Aptos"/>
-                <a:ea typeface="Yu Gothic"/>
+                <a:latin typeface="Noto Sans JP"/>
+                <a:ea typeface="Noto Sans JP"/>
               </a:rPr>
               <a:t>内容</a:t>
             </a:r>
@@ -870,8 +870,8 @@
                 <a:solidFill>
                   <a:srgbClr val="414242"/>
                 </a:solidFill>
-                <a:latin typeface="Aptos"/>
-                <a:ea typeface="Yu Gothic"/>
+                <a:latin typeface="Noto Sans JP"/>
+                <a:ea typeface="Noto Sans JP"/>
               </a:rPr>
               <a:t>扱い</a:t>
             </a:r>
@@ -936,8 +936,8 @@
                 <a:solidFill>
                   <a:srgbClr val="414242"/>
                 </a:solidFill>
-                <a:latin typeface="Aptos"/>
-                <a:ea typeface="Yu Gothic"/>
+                <a:latin typeface="Noto Sans JP"/>
+                <a:ea typeface="Noto Sans JP"/>
               </a:rPr>
               <a:t>標準機能</a:t>
             </a:r>
@@ -1002,8 +1002,8 @@
                 <a:solidFill>
                   <a:srgbClr val="6D7375"/>
                 </a:solidFill>
-                <a:latin typeface="Aptos"/>
-                <a:ea typeface="Yu Gothic"/>
+                <a:latin typeface="Noto Sans JP"/>
+                <a:ea typeface="Noto Sans JP"/>
               </a:rPr>
               <a:t>録音、文字起こし、AI要約、kintone活動履歴登録、kintoneレコード紐付け、チーム内データ確認</a:t>
             </a:r>
@@ -1068,8 +1068,8 @@
                 <a:solidFill>
                   <a:srgbClr val="6D7375"/>
                 </a:solidFill>
-                <a:latin typeface="Aptos"/>
-                <a:ea typeface="Yu Gothic"/>
+                <a:latin typeface="Noto Sans JP"/>
+                <a:ea typeface="Noto Sans JP"/>
               </a:rPr>
               <a:t>kintone Pack本体に含める</a:t>
             </a:r>
@@ -1134,8 +1134,8 @@
                 <a:solidFill>
                   <a:srgbClr val="414242"/>
                 </a:solidFill>
-                <a:latin typeface="Aptos"/>
-                <a:ea typeface="Yu Gothic"/>
+                <a:latin typeface="Noto Sans JP"/>
+                <a:ea typeface="Noto Sans JP"/>
               </a:rPr>
               <a:t>標準サポート</a:t>
             </a:r>
@@ -1200,8 +1200,8 @@
                 <a:solidFill>
                   <a:srgbClr val="6D7375"/>
                 </a:solidFill>
-                <a:latin typeface="Aptos"/>
-                <a:ea typeface="Yu Gothic"/>
+                <a:latin typeface="Noto Sans JP"/>
+                <a:ea typeface="Noto Sans JP"/>
               </a:rPr>
               <a:t>ヘルプページ、FAQ、メール等の問い合わせ対応、既定のkintone連携手順案内</a:t>
             </a:r>
@@ -1266,8 +1266,8 @@
                 <a:solidFill>
                   <a:srgbClr val="6D7375"/>
                 </a:solidFill>
-                <a:latin typeface="Aptos"/>
-                <a:ea typeface="Yu Gothic"/>
+                <a:latin typeface="Noto Sans JP"/>
+                <a:ea typeface="Noto Sans JP"/>
               </a:rPr>
               <a:t>問い合わせベースで対応</a:t>
             </a:r>
@@ -1332,8 +1332,8 @@
                 <a:solidFill>
                   <a:srgbClr val="414242"/>
                 </a:solidFill>
-                <a:latin typeface="Aptos"/>
-                <a:ea typeface="Yu Gothic"/>
+                <a:latin typeface="Noto Sans JP"/>
+                <a:ea typeface="Noto Sans JP"/>
               </a:rPr>
               <a:t>有償支援</a:t>
             </a:r>
@@ -1398,8 +1398,8 @@
                 <a:solidFill>
                   <a:srgbClr val="6D7375"/>
                 </a:solidFill>
-                <a:latin typeface="Aptos"/>
-                <a:ea typeface="Yu Gothic"/>
+                <a:latin typeface="Noto Sans JP"/>
+                <a:ea typeface="Noto Sans JP"/>
               </a:rPr>
               <a:t>初期設定支援、項目設計、フィールドマッピング、管理者向け説明会、月1回相談</a:t>
             </a:r>
@@ -1464,8 +1464,8 @@
                 <a:solidFill>
                   <a:srgbClr val="6D7375"/>
                 </a:solidFill>
-                <a:latin typeface="Aptos"/>
-                <a:ea typeface="Yu Gothic"/>
+                <a:latin typeface="Noto Sans JP"/>
+                <a:ea typeface="Noto Sans JP"/>
               </a:rPr>
               <a:t>別途支援として提案</a:t>
             </a:r>
@@ -1530,8 +1530,8 @@
                 <a:solidFill>
                   <a:srgbClr val="414242"/>
                 </a:solidFill>
-                <a:latin typeface="Aptos"/>
-                <a:ea typeface="Yu Gothic"/>
+                <a:latin typeface="Noto Sans JP"/>
+                <a:ea typeface="Noto Sans JP"/>
               </a:rPr>
               <a:t>対象外</a:t>
             </a:r>
@@ -1596,8 +1596,8 @@
                 <a:solidFill>
                   <a:srgbClr val="6D7375"/>
                 </a:solidFill>
-                <a:latin typeface="Aptos"/>
-                <a:ea typeface="Yu Gothic"/>
+                <a:latin typeface="Noto Sans JP"/>
+                <a:ea typeface="Noto Sans JP"/>
               </a:rPr>
               <a:t>業務フロー整理、分析設計、個別ダッシュボード構築、個別レポート作成</a:t>
             </a:r>
@@ -1662,8 +1662,8 @@
                 <a:solidFill>
                   <a:srgbClr val="6D7375"/>
                 </a:solidFill>
-                <a:latin typeface="Aptos"/>
-                <a:ea typeface="Yu Gothic"/>
+                <a:latin typeface="Noto Sans JP"/>
+                <a:ea typeface="Noto Sans JP"/>
               </a:rPr>
               <a:t>別提案</a:t>
             </a:r>
@@ -1755,8 +1755,8 @@
                 <a:solidFill>
                   <a:srgbClr val="6D7375"/>
                 </a:solidFill>
-                <a:latin typeface="Aptos"/>
-                <a:ea typeface="Yu Gothic"/>
+                <a:latin typeface="Noto Sans JP"/>
+                <a:ea typeface="Noto Sans JP"/>
               </a:rPr>
               <a:t>Support Boundary</a:t>
             </a:r>
@@ -1792,8 +1792,8 @@
                 <a:solidFill>
                   <a:srgbClr val="414242"/>
                 </a:solidFill>
-                <a:latin typeface="Aptos"/>
-                <a:ea typeface="Yu Gothic"/>
+                <a:latin typeface="Noto Sans JP"/>
+                <a:ea typeface="Noto Sans JP"/>
               </a:rPr>
               <a:t>FrontAgent</a:t>
             </a:r>
@@ -1829,8 +1829,8 @@
                 <a:solidFill>
                   <a:srgbClr val="414242"/>
                 </a:solidFill>
-                <a:latin typeface="Aptos"/>
-                <a:ea typeface="Yu Gothic"/>
+                <a:latin typeface="Noto Sans JP"/>
+                <a:ea typeface="Noto Sans JP"/>
               </a:rPr>
               <a:t>標準機能と個別支援を分け、本体価格を安く見せる</a:t>
             </a:r>
@@ -1924,8 +1924,8 @@
                 <a:solidFill>
                   <a:srgbClr val="6D7375"/>
                 </a:solidFill>
-                <a:latin typeface="Aptos"/>
-                <a:ea typeface="Yu Gothic"/>
+                <a:latin typeface="Noto Sans JP"/>
+                <a:ea typeface="Noto Sans JP"/>
               </a:rPr>
               <a:t>見た目の本体価格を安く保ち、個別対応は別枠で回収する</a:t>
             </a:r>
@@ -1961,8 +1961,8 @@
                 <a:solidFill>
                   <a:srgbClr val="6D7375"/>
                 </a:solidFill>
-                <a:latin typeface="Aptos"/>
-                <a:ea typeface="Yu Gothic"/>
+                <a:latin typeface="Noto Sans JP"/>
+                <a:ea typeface="Noto Sans JP"/>
               </a:rPr>
               <a:t>10</a:t>
             </a:r>
@@ -2002,7 +2002,7 @@
                 <a:solidFill>
                   <a:srgbClr val="FF7143"/>
                 </a:solidFill>
-                <a:ea typeface="Yu Gothic"/>
+                <a:ea typeface="Noto Sans JP"/>
               </a:rPr>
               <a:t/>
             </a:r>
@@ -2092,8 +2092,8 @@
                 <a:solidFill>
                   <a:srgbClr val="414242"/>
                 </a:solidFill>
-                <a:latin typeface="Aptos"/>
-                <a:ea typeface="Yu Gothic"/>
+                <a:latin typeface="Noto Sans JP"/>
+                <a:ea typeface="Noto Sans JP"/>
               </a:rPr>
               <a:t>GTM Positioning</a:t>
             </a:r>
@@ -2162,7 +2162,7 @@
                 <a:solidFill>
                   <a:srgbClr val="FF7143"/>
                 </a:solidFill>
-                <a:ea typeface="Yu Gothic"/>
+                <a:ea typeface="Noto Sans JP"/>
               </a:rPr>
               <a:t>1</a:t>
             </a:r>
@@ -2198,8 +2198,8 @@
                 <a:solidFill>
                   <a:srgbClr val="414242"/>
                 </a:solidFill>
-                <a:latin typeface="Aptos"/>
-                <a:ea typeface="Yu Gothic"/>
+                <a:latin typeface="Noto Sans JP"/>
+                <a:ea typeface="Noto Sans JP"/>
               </a:rPr>
               <a:t>Log Lite</a:t>
             </a:r>
@@ -2235,8 +2235,8 @@
                 <a:solidFill>
                   <a:srgbClr val="6D7375"/>
                 </a:solidFill>
-                <a:latin typeface="Aptos"/>
-                <a:ea typeface="Yu Gothic"/>
+                <a:latin typeface="Noto Sans JP"/>
+                <a:ea typeface="Noto Sans JP"/>
               </a:rPr>
               <a:t>見せ球</a:t>
             </a:r>
@@ -2248,8 +2248,8 @@
                 <a:solidFill>
                   <a:srgbClr val="6D7375"/>
                 </a:solidFill>
-                <a:latin typeface="Aptos"/>
-                <a:ea typeface="Yu Gothic"/>
+                <a:latin typeface="Noto Sans JP"/>
+                <a:ea typeface="Noto Sans JP"/>
               </a:rPr>
               <a:t>1ID限定・連携なし</a:t>
             </a:r>
@@ -2318,7 +2318,7 @@
                 <a:solidFill>
                   <a:srgbClr val="FFFFFF"/>
                 </a:solidFill>
-                <a:ea typeface="Yu Gothic"/>
+                <a:ea typeface="Noto Sans JP"/>
               </a:rPr>
               <a:t>2</a:t>
             </a:r>
@@ -2354,8 +2354,8 @@
                 <a:solidFill>
                   <a:srgbClr val="414242"/>
                 </a:solidFill>
-                <a:latin typeface="Aptos"/>
-                <a:ea typeface="Yu Gothic"/>
+                <a:latin typeface="Noto Sans JP"/>
+                <a:ea typeface="Noto Sans JP"/>
               </a:rPr>
               <a:t>kintone Pack</a:t>
             </a:r>
@@ -2391,8 +2391,8 @@
                 <a:solidFill>
                   <a:srgbClr val="6D7375"/>
                 </a:solidFill>
-                <a:latin typeface="Aptos"/>
-                <a:ea typeface="Yu Gothic"/>
+                <a:latin typeface="Noto Sans JP"/>
+                <a:ea typeface="Noto Sans JP"/>
               </a:rPr>
               <a:t>本命</a:t>
             </a:r>
@@ -2404,8 +2404,8 @@
                 <a:solidFill>
                   <a:srgbClr val="6D7375"/>
                 </a:solidFill>
-                <a:latin typeface="Aptos"/>
-                <a:ea typeface="Yu Gothic"/>
+                <a:latin typeface="Noto Sans JP"/>
+                <a:ea typeface="Noto Sans JP"/>
               </a:rPr>
               <a:t>新規・部門利用</a:t>
             </a:r>
@@ -2474,7 +2474,7 @@
                 <a:solidFill>
                   <a:srgbClr val="FFFFFF"/>
                 </a:solidFill>
-                <a:ea typeface="Yu Gothic"/>
+                <a:ea typeface="Noto Sans JP"/>
               </a:rPr>
               <a:t>3</a:t>
             </a:r>
@@ -2510,8 +2510,8 @@
                 <a:solidFill>
                   <a:srgbClr val="414242"/>
                 </a:solidFill>
-                <a:latin typeface="Aptos"/>
-                <a:ea typeface="Yu Gothic"/>
+                <a:latin typeface="Noto Sans JP"/>
+                <a:ea typeface="Noto Sans JP"/>
               </a:rPr>
               <a:t>FrontAX</a:t>
             </a:r>
@@ -2547,8 +2547,8 @@
                 <a:solidFill>
                   <a:srgbClr val="6D7375"/>
                 </a:solidFill>
-                <a:latin typeface="Aptos"/>
-                <a:ea typeface="Yu Gothic"/>
+                <a:latin typeface="Noto Sans JP"/>
+                <a:ea typeface="Noto Sans JP"/>
               </a:rPr>
               <a:t>上位導線</a:t>
             </a:r>
@@ -2560,8 +2560,8 @@
                 <a:solidFill>
                   <a:srgbClr val="6D7375"/>
                 </a:solidFill>
-                <a:latin typeface="Aptos"/>
-                <a:ea typeface="Yu Gothic"/>
+                <a:latin typeface="Noto Sans JP"/>
+                <a:ea typeface="Noto Sans JP"/>
               </a:rPr>
               <a:t>既存・営業利用</a:t>
             </a:r>
@@ -2626,8 +2626,8 @@
                 <a:solidFill>
                   <a:srgbClr val="414242"/>
                 </a:solidFill>
-                <a:latin typeface="Aptos"/>
-                <a:ea typeface="Yu Gothic"/>
+                <a:latin typeface="Noto Sans JP"/>
+                <a:ea typeface="Noto Sans JP"/>
               </a:rPr>
               <a:t>有償支援は商品導線ではなく、必要時に付帯</a:t>
             </a:r>
@@ -2692,8 +2692,8 @@
                 <a:solidFill>
                   <a:srgbClr val="414242"/>
                 </a:solidFill>
-                <a:latin typeface="Aptos"/>
-                <a:ea typeface="Yu Gothic"/>
+                <a:latin typeface="Noto Sans JP"/>
+                <a:ea typeface="Noto Sans JP"/>
               </a:rPr>
               <a:t>位置づけ</a:t>
             </a:r>
@@ -2758,8 +2758,8 @@
                 <a:solidFill>
                   <a:srgbClr val="414242"/>
                 </a:solidFill>
-                <a:latin typeface="Aptos"/>
-                <a:ea typeface="Yu Gothic"/>
+                <a:latin typeface="Noto Sans JP"/>
+                <a:ea typeface="Noto Sans JP"/>
               </a:rPr>
               <a:t>対象</a:t>
             </a:r>
@@ -2824,8 +2824,8 @@
                 <a:solidFill>
                   <a:srgbClr val="414242"/>
                 </a:solidFill>
-                <a:latin typeface="Aptos"/>
-                <a:ea typeface="Yu Gothic"/>
+                <a:latin typeface="Noto Sans JP"/>
+                <a:ea typeface="Noto Sans JP"/>
               </a:rPr>
               <a:t>扱い</a:t>
             </a:r>
@@ -2890,8 +2890,8 @@
                 <a:solidFill>
                   <a:srgbClr val="414242"/>
                 </a:solidFill>
-                <a:latin typeface="Aptos"/>
-                <a:ea typeface="Yu Gothic"/>
+                <a:latin typeface="Noto Sans JP"/>
+                <a:ea typeface="Noto Sans JP"/>
               </a:rPr>
               <a:t>Log Lite</a:t>
             </a:r>
@@ -2903,8 +2903,8 @@
                 <a:solidFill>
                   <a:srgbClr val="414242"/>
                 </a:solidFill>
-                <a:latin typeface="Aptos"/>
-                <a:ea typeface="Yu Gothic"/>
+                <a:latin typeface="Noto Sans JP"/>
+                <a:ea typeface="Noto Sans JP"/>
               </a:rPr>
               <a:t>見せ球</a:t>
             </a:r>
@@ -2969,8 +2969,8 @@
                 <a:solidFill>
                   <a:srgbClr val="6D7375"/>
                 </a:solidFill>
-                <a:latin typeface="Aptos"/>
-                <a:ea typeface="Yu Gothic"/>
+                <a:latin typeface="Noto Sans JP"/>
+                <a:ea typeface="Noto Sans JP"/>
               </a:rPr>
               <a:t>1名だけで最低限使いたい顧客、価格比較が強い顧客</a:t>
             </a:r>
@@ -3035,8 +3035,8 @@
                 <a:solidFill>
                   <a:srgbClr val="6D7375"/>
                 </a:solidFill>
-                <a:latin typeface="Aptos"/>
-                <a:ea typeface="Yu Gothic"/>
+                <a:latin typeface="Noto Sans JP"/>
+                <a:ea typeface="Noto Sans JP"/>
               </a:rPr>
               <a:t>1ID限定・追加ID不可。2ID以上はkintone Packで受ける。</a:t>
             </a:r>
@@ -3101,8 +3101,8 @@
                 <a:solidFill>
                   <a:srgbClr val="414242"/>
                 </a:solidFill>
-                <a:latin typeface="Aptos"/>
-                <a:ea typeface="Yu Gothic"/>
+                <a:latin typeface="Noto Sans JP"/>
+                <a:ea typeface="Noto Sans JP"/>
               </a:rPr>
               <a:t>kintone</a:t>
             </a:r>
@@ -3114,8 +3114,8 @@
                 <a:solidFill>
                   <a:srgbClr val="414242"/>
                 </a:solidFill>
-                <a:latin typeface="Aptos"/>
-                <a:ea typeface="Yu Gothic"/>
+                <a:latin typeface="Noto Sans JP"/>
+                <a:ea typeface="Noto Sans JP"/>
               </a:rPr>
               <a:t>Pack</a:t>
             </a:r>
@@ -3127,8 +3127,8 @@
                 <a:solidFill>
                   <a:srgbClr val="414242"/>
                 </a:solidFill>
-                <a:latin typeface="Aptos"/>
-                <a:ea typeface="Yu Gothic"/>
+                <a:latin typeface="Noto Sans JP"/>
+                <a:ea typeface="Noto Sans JP"/>
               </a:rPr>
               <a:t>本命</a:t>
             </a:r>
@@ -3193,8 +3193,8 @@
                 <a:solidFill>
                   <a:srgbClr val="6D7375"/>
                 </a:solidFill>
-                <a:latin typeface="Aptos"/>
-                <a:ea typeface="Yu Gothic"/>
+                <a:latin typeface="Noto Sans JP"/>
+                <a:ea typeface="Noto Sans JP"/>
               </a:rPr>
               <a:t>kintoneに顧客接点データを残したい新規・部門利用</a:t>
             </a:r>
@@ -3259,8 +3259,8 @@
                 <a:solidFill>
                   <a:srgbClr val="6D7375"/>
                 </a:solidFill>
-                <a:latin typeface="Aptos"/>
-                <a:ea typeface="Yu Gothic"/>
+                <a:latin typeface="Noto Sans JP"/>
+                <a:ea typeface="Noto Sans JP"/>
               </a:rPr>
               <a:t>1IDからの連携パック。追加IDも同一単価で積み上げる。</a:t>
             </a:r>
@@ -3325,8 +3325,8 @@
                 <a:solidFill>
                   <a:srgbClr val="414242"/>
                 </a:solidFill>
-                <a:latin typeface="Aptos"/>
-                <a:ea typeface="Yu Gothic"/>
+                <a:latin typeface="Noto Sans JP"/>
+                <a:ea typeface="Noto Sans JP"/>
               </a:rPr>
               <a:t>FrontAX</a:t>
             </a:r>
@@ -3338,8 +3338,8 @@
                 <a:solidFill>
                   <a:srgbClr val="414242"/>
                 </a:solidFill>
-                <a:latin typeface="Aptos"/>
-                <a:ea typeface="Yu Gothic"/>
+                <a:latin typeface="Noto Sans JP"/>
+                <a:ea typeface="Noto Sans JP"/>
               </a:rPr>
               <a:t>上位導線</a:t>
             </a:r>
@@ -3404,8 +3404,8 @@
                 <a:solidFill>
                   <a:srgbClr val="6D7375"/>
                 </a:solidFill>
-                <a:latin typeface="Aptos"/>
-                <a:ea typeface="Yu Gothic"/>
+                <a:latin typeface="Noto Sans JP"/>
+                <a:ea typeface="Noto Sans JP"/>
               </a:rPr>
               <a:t>既存ユーザーのうち、年商200億円規模かつ営業利用</a:t>
             </a:r>
@@ -3470,8 +3470,8 @@
                 <a:solidFill>
                   <a:srgbClr val="6D7375"/>
                 </a:solidFill>
-                <a:latin typeface="Aptos"/>
-                <a:ea typeface="Yu Gothic"/>
+                <a:latin typeface="Noto Sans JP"/>
+                <a:ea typeface="Noto Sans JP"/>
               </a:rPr>
               <a:t>Packとは別の上位提案。</a:t>
             </a:r>
@@ -3536,8 +3536,8 @@
                 <a:solidFill>
                   <a:srgbClr val="414242"/>
                 </a:solidFill>
-                <a:latin typeface="Aptos"/>
-                <a:ea typeface="Yu Gothic"/>
+                <a:latin typeface="Noto Sans JP"/>
+                <a:ea typeface="Noto Sans JP"/>
               </a:rPr>
               <a:t>有償支援</a:t>
             </a:r>
@@ -3549,8 +3549,8 @@
                 <a:solidFill>
                   <a:srgbClr val="414242"/>
                 </a:solidFill>
-                <a:latin typeface="Aptos"/>
-                <a:ea typeface="Yu Gothic"/>
+                <a:latin typeface="Noto Sans JP"/>
+                <a:ea typeface="Noto Sans JP"/>
               </a:rPr>
               <a:t>付帯</a:t>
             </a:r>
@@ -3615,8 +3615,8 @@
                 <a:solidFill>
                   <a:srgbClr val="6D7375"/>
                 </a:solidFill>
-                <a:latin typeface="Aptos"/>
-                <a:ea typeface="Yu Gothic"/>
+                <a:latin typeface="Noto Sans JP"/>
+                <a:ea typeface="Noto Sans JP"/>
               </a:rPr>
               <a:t>個別設定・項目設計・相談が必要な案件</a:t>
             </a:r>
@@ -3681,8 +3681,8 @@
                 <a:solidFill>
                   <a:srgbClr val="6D7375"/>
                 </a:solidFill>
-                <a:latin typeface="Aptos"/>
-                <a:ea typeface="Yu Gothic"/>
+                <a:latin typeface="Noto Sans JP"/>
+                <a:ea typeface="Noto Sans JP"/>
               </a:rPr>
               <a:t>Pack / FrontAXに必要時だけ付ける。</a:t>
             </a:r>
@@ -3774,8 +3774,8 @@
                 <a:solidFill>
                   <a:srgbClr val="6D7375"/>
                 </a:solidFill>
-                <a:latin typeface="Aptos"/>
-                <a:ea typeface="Yu Gothic"/>
+                <a:latin typeface="Noto Sans JP"/>
+                <a:ea typeface="Noto Sans JP"/>
               </a:rPr>
               <a:t>GTM</a:t>
             </a:r>
@@ -3811,8 +3811,8 @@
                 <a:solidFill>
                   <a:srgbClr val="414242"/>
                 </a:solidFill>
-                <a:latin typeface="Aptos"/>
-                <a:ea typeface="Yu Gothic"/>
+                <a:latin typeface="Noto Sans JP"/>
+                <a:ea typeface="Noto Sans JP"/>
               </a:rPr>
               <a:t>FrontAgent</a:t>
             </a:r>
@@ -3848,8 +3848,8 @@
                 <a:solidFill>
                   <a:srgbClr val="414242"/>
                 </a:solidFill>
-                <a:latin typeface="Aptos"/>
-                <a:ea typeface="Yu Gothic"/>
+                <a:latin typeface="Noto Sans JP"/>
+                <a:ea typeface="Noto Sans JP"/>
               </a:rPr>
               <a:t>GTMは移管導線ではなく、顧客条件ごとの置き場所にする</a:t>
             </a:r>
@@ -3943,8 +3943,8 @@
                 <a:solidFill>
                   <a:srgbClr val="6D7375"/>
                 </a:solidFill>
-                <a:latin typeface="Aptos"/>
-                <a:ea typeface="Yu Gothic"/>
+                <a:latin typeface="Noto Sans JP"/>
+                <a:ea typeface="Noto Sans JP"/>
               </a:rPr>
               <a:t>Log Liteは単独の見せ球。有償支援は必要時だけ付帯する</a:t>
             </a:r>
@@ -3980,8 +3980,8 @@
                 <a:solidFill>
                   <a:srgbClr val="6D7375"/>
                 </a:solidFill>
-                <a:latin typeface="Aptos"/>
-                <a:ea typeface="Yu Gothic"/>
+                <a:latin typeface="Noto Sans JP"/>
+                <a:ea typeface="Noto Sans JP"/>
               </a:rPr>
               <a:t>11</a:t>
             </a:r>
@@ -4021,7 +4021,7 @@
                 <a:solidFill>
                   <a:srgbClr val="FF7143"/>
                 </a:solidFill>
-                <a:ea typeface="Yu Gothic"/>
+                <a:ea typeface="Noto Sans JP"/>
               </a:rPr>
               <a:t/>
             </a:r>
@@ -4111,8 +4111,8 @@
                 <a:solidFill>
                   <a:srgbClr val="6D7375"/>
                 </a:solidFill>
-                <a:latin typeface="Aptos"/>
-                <a:ea typeface="Yu Gothic"/>
+                <a:latin typeface="Noto Sans JP"/>
+                <a:ea typeface="Noto Sans JP"/>
               </a:rPr>
               <a:t>PRICE ANCHOR / CORE PACK</a:t>
             </a:r>
@@ -4181,7 +4181,7 @@
                 <a:solidFill>
                   <a:srgbClr val="FF7143"/>
                 </a:solidFill>
-                <a:ea typeface="Yu Gothic"/>
+                <a:ea typeface="Noto Sans JP"/>
               </a:rPr>
               <a:t>1</a:t>
             </a:r>
@@ -4217,8 +4217,8 @@
                 <a:solidFill>
                   <a:srgbClr val="414242"/>
                 </a:solidFill>
-                <a:latin typeface="Aptos"/>
-                <a:ea typeface="Yu Gothic"/>
+                <a:latin typeface="Noto Sans JP"/>
+                <a:ea typeface="Noto Sans JP"/>
               </a:rPr>
               <a:t>Log Lite</a:t>
             </a:r>
@@ -4254,8 +4254,8 @@
                 <a:solidFill>
                   <a:srgbClr val="6D7375"/>
                 </a:solidFill>
-                <a:latin typeface="Aptos"/>
-                <a:ea typeface="Yu Gothic"/>
+                <a:latin typeface="Noto Sans JP"/>
+                <a:ea typeface="Noto Sans JP"/>
               </a:rPr>
               <a:t>1ID限定 / 980円</a:t>
             </a:r>
@@ -4267,8 +4267,8 @@
                 <a:solidFill>
                   <a:srgbClr val="6D7375"/>
                 </a:solidFill>
-                <a:latin typeface="Aptos"/>
-                <a:ea typeface="Yu Gothic"/>
+                <a:latin typeface="Noto Sans JP"/>
+                <a:ea typeface="Noto Sans JP"/>
               </a:rPr>
               <a:t>追加ID不可</a:t>
             </a:r>
@@ -4337,7 +4337,7 @@
                 <a:solidFill>
                   <a:srgbClr val="FFFFFF"/>
                 </a:solidFill>
-                <a:ea typeface="Yu Gothic"/>
+                <a:ea typeface="Noto Sans JP"/>
               </a:rPr>
               <a:t>2</a:t>
             </a:r>
@@ -4373,8 +4373,8 @@
                 <a:solidFill>
                   <a:srgbClr val="414242"/>
                 </a:solidFill>
-                <a:latin typeface="Aptos"/>
-                <a:ea typeface="Yu Gothic"/>
+                <a:latin typeface="Noto Sans JP"/>
+                <a:ea typeface="Noto Sans JP"/>
               </a:rPr>
               <a:t>kintone Pack</a:t>
             </a:r>
@@ -4410,8 +4410,8 @@
                 <a:solidFill>
                   <a:srgbClr val="6D7375"/>
                 </a:solidFill>
-                <a:latin typeface="Aptos"/>
-                <a:ea typeface="Yu Gothic"/>
+                <a:latin typeface="Noto Sans JP"/>
+                <a:ea typeface="Noto Sans JP"/>
               </a:rPr>
               <a:t>初年度限定 2,980円 / ID</a:t>
             </a:r>
@@ -4423,8 +4423,8 @@
                 <a:solidFill>
                   <a:srgbClr val="6D7375"/>
                 </a:solidFill>
-                <a:latin typeface="Aptos"/>
-                <a:ea typeface="Yu Gothic"/>
+                <a:latin typeface="Noto Sans JP"/>
+                <a:ea typeface="Noto Sans JP"/>
               </a:rPr>
               <a:t>2ID以上・連携はこちら</a:t>
             </a:r>
@@ -4522,7 +4522,7 @@
                 <a:solidFill>
                   <a:srgbClr val="FF7143"/>
                 </a:solidFill>
-                <a:ea typeface="Yu Gothic"/>
+                <a:ea typeface="Noto Sans JP"/>
               </a:rPr>
               <a:t>1</a:t>
             </a:r>
@@ -4558,8 +4558,8 @@
                 <a:solidFill>
                   <a:srgbClr val="414242"/>
                 </a:solidFill>
-                <a:latin typeface="Aptos"/>
-                <a:ea typeface="Yu Gothic"/>
+                <a:latin typeface="Noto Sans JP"/>
+                <a:ea typeface="Noto Sans JP"/>
               </a:rPr>
               <a:t>Log Lite</a:t>
             </a:r>
@@ -4595,8 +4595,8 @@
                 <a:solidFill>
                   <a:srgbClr val="6D7375"/>
                 </a:solidFill>
-                <a:latin typeface="Aptos"/>
-                <a:ea typeface="Yu Gothic"/>
+                <a:latin typeface="Noto Sans JP"/>
+                <a:ea typeface="Noto Sans JP"/>
               </a:rPr>
               <a:t>1ID限定・980円/月の見せ球。追加IDは不可。月1,800分・1ログ5時間・AI要約100回までにする。</a:t>
             </a:r>
@@ -4665,7 +4665,7 @@
                 <a:solidFill>
                   <a:srgbClr val="FFFFFF"/>
                 </a:solidFill>
-                <a:ea typeface="Yu Gothic"/>
+                <a:ea typeface="Noto Sans JP"/>
               </a:rPr>
               <a:t>2</a:t>
             </a:r>
@@ -4701,8 +4701,8 @@
                 <a:solidFill>
                   <a:srgbClr val="414242"/>
                 </a:solidFill>
-                <a:latin typeface="Aptos"/>
-                <a:ea typeface="Yu Gothic"/>
+                <a:latin typeface="Noto Sans JP"/>
+                <a:ea typeface="Noto Sans JP"/>
               </a:rPr>
               <a:t>kintone Pack</a:t>
             </a:r>
@@ -4738,8 +4738,8 @@
                 <a:solidFill>
                   <a:srgbClr val="6D7375"/>
                 </a:solidFill>
-                <a:latin typeface="Aptos"/>
-                <a:ea typeface="Yu Gothic"/>
+                <a:latin typeface="Noto Sans JP"/>
+                <a:ea typeface="Noto Sans JP"/>
               </a:rPr>
               <a:t>2ID以上・追加ID・kintone連携を受ける本命プラン。2,980円は初年度のみ、2年目以降は通常単価。</a:t>
             </a:r>
@@ -4804,8 +4804,8 @@
                 <a:solidFill>
                   <a:srgbClr val="6D7375"/>
                 </a:solidFill>
-                <a:latin typeface="Aptos"/>
-                <a:ea typeface="Yu Gothic"/>
+                <a:latin typeface="Noto Sans JP"/>
+                <a:ea typeface="Noto Sans JP"/>
               </a:rPr>
               <a:t>Executive Summary</a:t>
             </a:r>
@@ -4841,8 +4841,8 @@
                 <a:solidFill>
                   <a:srgbClr val="414242"/>
                 </a:solidFill>
-                <a:latin typeface="Aptos"/>
-                <a:ea typeface="Yu Gothic"/>
+                <a:latin typeface="Noto Sans JP"/>
+                <a:ea typeface="Noto Sans JP"/>
               </a:rPr>
               <a:t>FrontAgent</a:t>
             </a:r>
@@ -4878,8 +4878,8 @@
                 <a:solidFill>
                   <a:srgbClr val="414242"/>
                 </a:solidFill>
-                <a:latin typeface="Aptos"/>
-                <a:ea typeface="Yu Gothic"/>
+                <a:latin typeface="Noto Sans JP"/>
+                <a:ea typeface="Noto Sans JP"/>
               </a:rPr>
               <a:t>提案の中心は、Log Liteとkintone Packの2層設計</a:t>
             </a:r>
@@ -4973,8 +4973,8 @@
                 <a:solidFill>
                   <a:srgbClr val="6D7375"/>
                 </a:solidFill>
-                <a:latin typeface="Aptos"/>
-                <a:ea typeface="Yu Gothic"/>
+                <a:latin typeface="Noto Sans JP"/>
+                <a:ea typeface="Noto Sans JP"/>
               </a:rPr>
               <a:t>見せ球のLog Liteと、本命のkintone Packを分ける</a:t>
             </a:r>
@@ -5010,8 +5010,8 @@
                 <a:solidFill>
                   <a:srgbClr val="6D7375"/>
                 </a:solidFill>
-                <a:latin typeface="Aptos"/>
-                <a:ea typeface="Yu Gothic"/>
+                <a:latin typeface="Noto Sans JP"/>
+                <a:ea typeface="Noto Sans JP"/>
               </a:rPr>
               <a:t>02</a:t>
             </a:r>
@@ -5051,7 +5051,7 @@
                 <a:solidFill>
                   <a:srgbClr val="FF7143"/>
                 </a:solidFill>
-                <a:ea typeface="Yu Gothic"/>
+                <a:ea typeface="Noto Sans JP"/>
               </a:rPr>
               <a:t/>
             </a:r>
@@ -5141,8 +5141,8 @@
                 <a:solidFill>
                   <a:srgbClr val="414242"/>
                 </a:solidFill>
-                <a:latin typeface="Aptos"/>
-                <a:ea typeface="Yu Gothic"/>
+                <a:latin typeface="Noto Sans JP"/>
+                <a:ea typeface="Noto Sans JP"/>
               </a:rPr>
               <a:t>比較対象</a:t>
             </a:r>
@@ -5207,8 +5207,8 @@
                 <a:solidFill>
                   <a:srgbClr val="414242"/>
                 </a:solidFill>
-                <a:latin typeface="Aptos"/>
-                <a:ea typeface="Yu Gothic"/>
+                <a:latin typeface="Noto Sans JP"/>
+                <a:ea typeface="Noto Sans JP"/>
               </a:rPr>
               <a:t>価格アンカー</a:t>
             </a:r>
@@ -5273,8 +5273,8 @@
                 <a:solidFill>
                   <a:srgbClr val="414242"/>
                 </a:solidFill>
-                <a:latin typeface="Aptos"/>
-                <a:ea typeface="Yu Gothic"/>
+                <a:latin typeface="Noto Sans JP"/>
+                <a:ea typeface="Noto Sans JP"/>
               </a:rPr>
               <a:t>示唆</a:t>
             </a:r>
@@ -5339,8 +5339,8 @@
                 <a:solidFill>
                   <a:srgbClr val="414242"/>
                 </a:solidFill>
-                <a:latin typeface="Aptos"/>
-                <a:ea typeface="Yu Gothic"/>
+                <a:latin typeface="Noto Sans JP"/>
+                <a:ea typeface="Noto Sans JP"/>
               </a:rPr>
               <a:t>kintone本体</a:t>
             </a:r>
@@ -5405,8 +5405,8 @@
                 <a:solidFill>
                   <a:srgbClr val="6D7375"/>
                 </a:solidFill>
-                <a:latin typeface="Aptos"/>
-                <a:ea typeface="Yu Gothic"/>
+                <a:latin typeface="Noto Sans JP"/>
+                <a:ea typeface="Noto Sans JP"/>
               </a:rPr>
               <a:t>1,000円 / 1,800円 / 3,000円</a:t>
             </a:r>
@@ -5418,8 +5418,8 @@
                 <a:solidFill>
                   <a:srgbClr val="6D7375"/>
                 </a:solidFill>
-                <a:latin typeface="Aptos"/>
-                <a:ea typeface="Yu Gothic"/>
+                <a:latin typeface="Noto Sans JP"/>
+                <a:ea typeface="Noto Sans JP"/>
               </a:rPr>
               <a:t>ライト・スタンダード・ワイド</a:t>
             </a:r>
@@ -5484,8 +5484,8 @@
                 <a:solidFill>
                   <a:srgbClr val="6D7375"/>
                 </a:solidFill>
-                <a:latin typeface="Aptos"/>
-                <a:ea typeface="Yu Gothic"/>
+                <a:latin typeface="Noto Sans JP"/>
+                <a:ea typeface="Noto Sans JP"/>
               </a:rPr>
               <a:t>初見では、1IDあたり1000円台の印象が強い。</a:t>
             </a:r>
@@ -5550,8 +5550,8 @@
                 <a:solidFill>
                   <a:srgbClr val="414242"/>
                 </a:solidFill>
-                <a:latin typeface="Aptos"/>
-                <a:ea typeface="Yu Gothic"/>
+                <a:latin typeface="Noto Sans JP"/>
+                <a:ea typeface="Noto Sans JP"/>
               </a:rPr>
               <a:t>kintone連携サービス</a:t>
             </a:r>
@@ -5616,8 +5616,8 @@
                 <a:solidFill>
                   <a:srgbClr val="6D7375"/>
                 </a:solidFill>
-                <a:latin typeface="Aptos"/>
-                <a:ea typeface="Yu Gothic"/>
+                <a:latin typeface="Noto Sans JP"/>
+                <a:ea typeface="Noto Sans JP"/>
               </a:rPr>
               <a:t>月額7,000円から / 年額12万円など</a:t>
             </a:r>
@@ -5682,8 +5682,8 @@
                 <a:solidFill>
                   <a:srgbClr val="6D7375"/>
                 </a:solidFill>
-                <a:latin typeface="Aptos"/>
-                <a:ea typeface="Yu Gothic"/>
+                <a:latin typeface="Noto Sans JP"/>
+                <a:ea typeface="Noto Sans JP"/>
               </a:rPr>
               <a:t>1ID単価だけでなく、環境単位・ID上限付きパックも説明しやすい。</a:t>
             </a:r>
@@ -5748,8 +5748,8 @@
                 <a:solidFill>
                   <a:srgbClr val="414242"/>
                 </a:solidFill>
-                <a:latin typeface="Aptos"/>
-                <a:ea typeface="Yu Gothic"/>
+                <a:latin typeface="Noto Sans JP"/>
+                <a:ea typeface="Noto Sans JP"/>
               </a:rPr>
               <a:t>AI議事録</a:t>
             </a:r>
@@ -5814,8 +5814,8 @@
                 <a:solidFill>
                   <a:srgbClr val="6D7375"/>
                 </a:solidFill>
-                <a:latin typeface="Aptos"/>
-                <a:ea typeface="Yu Gothic"/>
+                <a:latin typeface="Noto Sans JP"/>
+                <a:ea typeface="Noto Sans JP"/>
               </a:rPr>
               <a:t>1000円台から5000円台</a:t>
             </a:r>
@@ -5880,8 +5880,8 @@
                 <a:solidFill>
                   <a:srgbClr val="6D7375"/>
                 </a:solidFill>
-                <a:latin typeface="Aptos"/>
-                <a:ea typeface="Yu Gothic"/>
+                <a:latin typeface="Noto Sans JP"/>
+                <a:ea typeface="Noto Sans JP"/>
               </a:rPr>
               <a:t>Nottaは分数・1回上限・AI要約回数でプラン差を出している。</a:t>
             </a:r>
@@ -5973,8 +5973,8 @@
                 <a:solidFill>
                   <a:srgbClr val="6D7375"/>
                 </a:solidFill>
-                <a:latin typeface="Aptos"/>
-                <a:ea typeface="Yu Gothic"/>
+                <a:latin typeface="Noto Sans JP"/>
+                <a:ea typeface="Noto Sans JP"/>
               </a:rPr>
               <a:t>Market Context</a:t>
             </a:r>
@@ -6010,8 +6010,8 @@
                 <a:solidFill>
                   <a:srgbClr val="414242"/>
                 </a:solidFill>
-                <a:latin typeface="Aptos"/>
-                <a:ea typeface="Yu Gothic"/>
+                <a:latin typeface="Noto Sans JP"/>
+                <a:ea typeface="Noto Sans JP"/>
               </a:rPr>
               <a:t>FrontAgent</a:t>
             </a:r>
@@ -6047,8 +6047,8 @@
                 <a:solidFill>
                   <a:srgbClr val="414242"/>
                 </a:solidFill>
-                <a:latin typeface="Aptos"/>
-                <a:ea typeface="Yu Gothic"/>
+                <a:latin typeface="Noto Sans JP"/>
+                <a:ea typeface="Noto Sans JP"/>
               </a:rPr>
               <a:t>kintone利用者の価格感覚は、1000円台から始まる</a:t>
             </a:r>
@@ -6142,8 +6142,8 @@
                 <a:solidFill>
                   <a:srgbClr val="6D7375"/>
                 </a:solidFill>
-                <a:latin typeface="Aptos"/>
-                <a:ea typeface="Yu Gothic"/>
+                <a:latin typeface="Noto Sans JP"/>
+                <a:ea typeface="Noto Sans JP"/>
               </a:rPr>
               <a:t>価格表示は1IDから始め、必要ID数で積み上げる</a:t>
             </a:r>
@@ -6179,8 +6179,8 @@
                 <a:solidFill>
                   <a:srgbClr val="6D7375"/>
                 </a:solidFill>
-                <a:latin typeface="Aptos"/>
-                <a:ea typeface="Yu Gothic"/>
+                <a:latin typeface="Noto Sans JP"/>
+                <a:ea typeface="Noto Sans JP"/>
               </a:rPr>
               <a:t>03</a:t>
             </a:r>
@@ -6220,7 +6220,7 @@
                 <a:solidFill>
                   <a:srgbClr val="FF7143"/>
                 </a:solidFill>
-                <a:ea typeface="Yu Gothic"/>
+                <a:ea typeface="Noto Sans JP"/>
               </a:rPr>
               <a:t/>
             </a:r>
@@ -6314,7 +6314,7 @@
                 <a:solidFill>
                   <a:srgbClr val="FF7143"/>
                 </a:solidFill>
-                <a:ea typeface="Yu Gothic"/>
+                <a:ea typeface="Noto Sans JP"/>
               </a:rPr>
               <a:t>1</a:t>
             </a:r>
@@ -6350,8 +6350,8 @@
                 <a:solidFill>
                   <a:srgbClr val="414242"/>
                 </a:solidFill>
-                <a:latin typeface="Aptos"/>
-                <a:ea typeface="Yu Gothic"/>
+                <a:latin typeface="Noto Sans JP"/>
+                <a:ea typeface="Noto Sans JP"/>
               </a:rPr>
               <a:t>見せ球</a:t>
             </a:r>
@@ -6387,8 +6387,8 @@
                 <a:solidFill>
                   <a:srgbClr val="6D7375"/>
                 </a:solidFill>
-                <a:latin typeface="Aptos"/>
-                <a:ea typeface="Yu Gothic"/>
+                <a:latin typeface="Noto Sans JP"/>
+                <a:ea typeface="Noto Sans JP"/>
               </a:rPr>
               <a:t>Log Liteは1ID限定 980円/月。Notta Premium基準の上限で、比較時の価格アンカーにする。</a:t>
             </a:r>
@@ -6457,7 +6457,7 @@
                 <a:solidFill>
                   <a:srgbClr val="FFFFFF"/>
                 </a:solidFill>
-                <a:ea typeface="Yu Gothic"/>
+                <a:ea typeface="Noto Sans JP"/>
               </a:rPr>
               <a:t>2</a:t>
             </a:r>
@@ -6493,8 +6493,8 @@
                 <a:solidFill>
                   <a:srgbClr val="414242"/>
                 </a:solidFill>
-                <a:latin typeface="Aptos"/>
-                <a:ea typeface="Yu Gothic"/>
+                <a:latin typeface="Noto Sans JP"/>
+                <a:ea typeface="Noto Sans JP"/>
               </a:rPr>
               <a:t>1ID連携</a:t>
             </a:r>
@@ -6530,8 +6530,8 @@
                 <a:solidFill>
                   <a:srgbClr val="6D7375"/>
                 </a:solidFill>
-                <a:latin typeface="Aptos"/>
-                <a:ea typeface="Yu Gothic"/>
+                <a:latin typeface="Noto Sans JP"/>
+                <a:ea typeface="Noto Sans JP"/>
               </a:rPr>
               <a:t>kintone Packも1IDから。初見の価格ハードルを下げる。</a:t>
             </a:r>
@@ -6600,7 +6600,7 @@
                 <a:solidFill>
                   <a:srgbClr val="FF7143"/>
                 </a:solidFill>
-                <a:ea typeface="Yu Gothic"/>
+                <a:ea typeface="Noto Sans JP"/>
               </a:rPr>
               <a:t>3</a:t>
             </a:r>
@@ -6636,8 +6636,8 @@
                 <a:solidFill>
                   <a:srgbClr val="414242"/>
                 </a:solidFill>
-                <a:latin typeface="Aptos"/>
-                <a:ea typeface="Yu Gothic"/>
+                <a:latin typeface="Noto Sans JP"/>
+                <a:ea typeface="Noto Sans JP"/>
               </a:rPr>
               <a:t>ID追加</a:t>
             </a:r>
@@ -6673,8 +6673,8 @@
                 <a:solidFill>
                   <a:srgbClr val="6D7375"/>
                 </a:solidFill>
-                <a:latin typeface="Aptos"/>
-                <a:ea typeface="Yu Gothic"/>
+                <a:latin typeface="Noto Sans JP"/>
+                <a:ea typeface="Noto Sans JP"/>
               </a:rPr>
               <a:t>追加IDまたは2ID以上はkintone Pack。Liteの安さを複数利用に広げない。</a:t>
             </a:r>
@@ -6743,7 +6743,7 @@
                 <a:solidFill>
                   <a:srgbClr val="FF7143"/>
                 </a:solidFill>
-                <a:ea typeface="Yu Gothic"/>
+                <a:ea typeface="Noto Sans JP"/>
               </a:rPr>
               <a:t>4</a:t>
             </a:r>
@@ -6779,8 +6779,8 @@
                 <a:solidFill>
                   <a:srgbClr val="414242"/>
                 </a:solidFill>
-                <a:latin typeface="Aptos"/>
-                <a:ea typeface="Yu Gothic"/>
+                <a:latin typeface="Noto Sans JP"/>
+                <a:ea typeface="Noto Sans JP"/>
               </a:rPr>
               <a:t>支援分離</a:t>
             </a:r>
@@ -6816,8 +6816,8 @@
                 <a:solidFill>
                   <a:srgbClr val="6D7375"/>
                 </a:solidFill>
-                <a:latin typeface="Aptos"/>
-                <a:ea typeface="Yu Gothic"/>
+                <a:latin typeface="Noto Sans JP"/>
+                <a:ea typeface="Noto Sans JP"/>
               </a:rPr>
               <a:t>個別設定や定例支援は本体に含めず、別途提案する。</a:t>
             </a:r>
@@ -6882,8 +6882,8 @@
                 <a:solidFill>
                   <a:srgbClr val="6D7375"/>
                 </a:solidFill>
-                <a:latin typeface="Aptos"/>
-                <a:ea typeface="Yu Gothic"/>
+                <a:latin typeface="Noto Sans JP"/>
+                <a:ea typeface="Noto Sans JP"/>
               </a:rPr>
               <a:t>Design Policy</a:t>
             </a:r>
@@ -6919,8 +6919,8 @@
                 <a:solidFill>
                   <a:srgbClr val="414242"/>
                 </a:solidFill>
-                <a:latin typeface="Aptos"/>
-                <a:ea typeface="Yu Gothic"/>
+                <a:latin typeface="Noto Sans JP"/>
+                <a:ea typeface="Noto Sans JP"/>
               </a:rPr>
               <a:t>FrontAgent</a:t>
             </a:r>
@@ -6956,8 +6956,8 @@
                 <a:solidFill>
                   <a:srgbClr val="414242"/>
                 </a:solidFill>
-                <a:latin typeface="Aptos"/>
-                <a:ea typeface="Yu Gothic"/>
+                <a:latin typeface="Noto Sans JP"/>
+                <a:ea typeface="Noto Sans JP"/>
               </a:rPr>
               <a:t>見せ球と本命を分け、価格感度と連携価値を両立する</a:t>
             </a:r>
@@ -7051,8 +7051,8 @@
                 <a:solidFill>
                   <a:srgbClr val="6D7375"/>
                 </a:solidFill>
-                <a:latin typeface="Aptos"/>
-                <a:ea typeface="Yu Gothic"/>
+                <a:latin typeface="Noto Sans JP"/>
+                <a:ea typeface="Noto Sans JP"/>
               </a:rPr>
               <a:t>本体価格を軽く見せ、個別対応は別枠で回収する</a:t>
             </a:r>
@@ -7088,8 +7088,8 @@
                 <a:solidFill>
                   <a:srgbClr val="6D7375"/>
                 </a:solidFill>
-                <a:latin typeface="Aptos"/>
-                <a:ea typeface="Yu Gothic"/>
+                <a:latin typeface="Noto Sans JP"/>
+                <a:ea typeface="Noto Sans JP"/>
               </a:rPr>
               <a:t>04</a:t>
             </a:r>
@@ -7129,7 +7129,7 @@
                 <a:solidFill>
                   <a:srgbClr val="FF7143"/>
                 </a:solidFill>
-                <a:ea typeface="Yu Gothic"/>
+                <a:ea typeface="Noto Sans JP"/>
               </a:rPr>
               <a:t/>
             </a:r>
@@ -7219,8 +7219,8 @@
                 <a:solidFill>
                   <a:srgbClr val="414242"/>
                 </a:solidFill>
-                <a:latin typeface="Aptos"/>
-                <a:ea typeface="Yu Gothic"/>
+                <a:latin typeface="Noto Sans JP"/>
+                <a:ea typeface="Noto Sans JP"/>
               </a:rPr>
               <a:t>プラン</a:t>
             </a:r>
@@ -7285,8 +7285,8 @@
                 <a:solidFill>
                   <a:srgbClr val="414242"/>
                 </a:solidFill>
-                <a:latin typeface="Aptos"/>
-                <a:ea typeface="Yu Gothic"/>
+                <a:latin typeface="Noto Sans JP"/>
+                <a:ea typeface="Noto Sans JP"/>
               </a:rPr>
               <a:t>役割・価格</a:t>
             </a:r>
@@ -7351,8 +7351,8 @@
                 <a:solidFill>
                   <a:srgbClr val="414242"/>
                 </a:solidFill>
-                <a:latin typeface="Aptos"/>
-                <a:ea typeface="Yu Gothic"/>
+                <a:latin typeface="Noto Sans JP"/>
+                <a:ea typeface="Noto Sans JP"/>
               </a:rPr>
               <a:t>主な機能</a:t>
             </a:r>
@@ -7417,8 +7417,8 @@
                 <a:solidFill>
                   <a:srgbClr val="414242"/>
                 </a:solidFill>
-                <a:latin typeface="Aptos"/>
-                <a:ea typeface="Yu Gothic"/>
+                <a:latin typeface="Noto Sans JP"/>
+                <a:ea typeface="Noto Sans JP"/>
               </a:rPr>
               <a:t>契約・支援</a:t>
             </a:r>
@@ -7483,8 +7483,8 @@
                 <a:solidFill>
                   <a:srgbClr val="414242"/>
                 </a:solidFill>
-                <a:latin typeface="Aptos"/>
-                <a:ea typeface="Yu Gothic"/>
+                <a:latin typeface="Noto Sans JP"/>
+                <a:ea typeface="Noto Sans JP"/>
               </a:rPr>
               <a:t>Log Lite</a:t>
             </a:r>
@@ -7549,8 +7549,8 @@
                 <a:solidFill>
                   <a:srgbClr val="6D7375"/>
                 </a:solidFill>
-                <a:latin typeface="Aptos"/>
-                <a:ea typeface="Yu Gothic"/>
+                <a:latin typeface="Noto Sans JP"/>
+                <a:ea typeface="Noto Sans JP"/>
               </a:rPr>
               <a:t>1ID限定の見せ球</a:t>
             </a:r>
@@ -7562,8 +7562,8 @@
                 <a:solidFill>
                   <a:srgbClr val="6D7375"/>
                 </a:solidFill>
-                <a:latin typeface="Aptos"/>
-                <a:ea typeface="Yu Gothic"/>
+                <a:latin typeface="Noto Sans JP"/>
+                <a:ea typeface="Noto Sans JP"/>
               </a:rPr>
               <a:t>980円 / 1ID / 月</a:t>
             </a:r>
@@ -7628,8 +7628,8 @@
                 <a:solidFill>
                   <a:srgbClr val="6D7375"/>
                 </a:solidFill>
-                <a:latin typeface="Aptos"/>
-                <a:ea typeface="Yu Gothic"/>
+                <a:latin typeface="Noto Sans JP"/>
+                <a:ea typeface="Noto Sans JP"/>
               </a:rPr>
               <a:t>録音、文字起こし、AI要約</a:t>
             </a:r>
@@ -7641,8 +7641,8 @@
                 <a:solidFill>
                   <a:srgbClr val="6D7375"/>
                 </a:solidFill>
-                <a:latin typeface="Aptos"/>
-                <a:ea typeface="Yu Gothic"/>
+                <a:latin typeface="Noto Sans JP"/>
+                <a:ea typeface="Noto Sans JP"/>
               </a:rPr>
               <a:t>月1,800分・1ログ5時間・要約100回まで。kintone連携なし。</a:t>
             </a:r>
@@ -7707,8 +7707,8 @@
                 <a:solidFill>
                   <a:srgbClr val="6D7375"/>
                 </a:solidFill>
-                <a:latin typeface="Aptos"/>
-                <a:ea typeface="Yu Gothic"/>
+                <a:latin typeface="Noto Sans JP"/>
+                <a:ea typeface="Noto Sans JP"/>
               </a:rPr>
               <a:t>パートナー限定。月契約可。追加ID不可。2ID以上はPack。</a:t>
             </a:r>
@@ -7773,8 +7773,8 @@
                 <a:solidFill>
                   <a:srgbClr val="414242"/>
                 </a:solidFill>
-                <a:latin typeface="Aptos"/>
-                <a:ea typeface="Yu Gothic"/>
+                <a:latin typeface="Noto Sans JP"/>
+                <a:ea typeface="Noto Sans JP"/>
               </a:rPr>
               <a:t>kintone</a:t>
             </a:r>
@@ -7786,8 +7786,8 @@
                 <a:solidFill>
                   <a:srgbClr val="414242"/>
                 </a:solidFill>
-                <a:latin typeface="Aptos"/>
-                <a:ea typeface="Yu Gothic"/>
+                <a:latin typeface="Noto Sans JP"/>
+                <a:ea typeface="Noto Sans JP"/>
               </a:rPr>
               <a:t>Pack</a:t>
             </a:r>
@@ -7852,8 +7852,8 @@
                 <a:solidFill>
                   <a:srgbClr val="6D7375"/>
                 </a:solidFill>
-                <a:latin typeface="Aptos"/>
-                <a:ea typeface="Yu Gothic"/>
+                <a:latin typeface="Noto Sans JP"/>
+                <a:ea typeface="Noto Sans JP"/>
               </a:rPr>
               <a:t>1IDから使えるkintone連携プラン</a:t>
             </a:r>
@@ -7865,8 +7865,8 @@
                 <a:solidFill>
                   <a:srgbClr val="6D7375"/>
                 </a:solidFill>
-                <a:latin typeface="Aptos"/>
-                <a:ea typeface="Yu Gothic"/>
+                <a:latin typeface="Noto Sans JP"/>
+                <a:ea typeface="Noto Sans JP"/>
               </a:rPr>
               <a:t>通常5,980円 / ID / 月</a:t>
             </a:r>
@@ -7931,8 +7931,8 @@
                 <a:solidFill>
                   <a:srgbClr val="6D7375"/>
                 </a:solidFill>
-                <a:latin typeface="Aptos"/>
-                <a:ea typeface="Yu Gothic"/>
+                <a:latin typeface="Noto Sans JP"/>
+                <a:ea typeface="Noto Sans JP"/>
               </a:rPr>
               <a:t>録音、文字起こし、AI要約、活動履歴登録、レコード紐付け、チーム確認</a:t>
             </a:r>
@@ -7997,8 +7997,8 @@
                 <a:solidFill>
                   <a:srgbClr val="6D7375"/>
                 </a:solidFill>
-                <a:latin typeface="Aptos"/>
-                <a:ea typeface="Yu Gothic"/>
+                <a:latin typeface="Noto Sans JP"/>
+                <a:ea typeface="Noto Sans JP"/>
               </a:rPr>
               <a:t>12ヶ月契約。2,980円/ID/月は初年度のみ。（LogLiteからの移管は対象外）</a:t>
             </a:r>
@@ -8090,8 +8090,8 @@
                 <a:solidFill>
                   <a:srgbClr val="6D7375"/>
                 </a:solidFill>
-                <a:latin typeface="Aptos"/>
-                <a:ea typeface="Yu Gothic"/>
+                <a:latin typeface="Noto Sans JP"/>
+                <a:ea typeface="Noto Sans JP"/>
               </a:rPr>
               <a:t>Plan Matrix</a:t>
             </a:r>
@@ -8127,8 +8127,8 @@
                 <a:solidFill>
                   <a:srgbClr val="414242"/>
                 </a:solidFill>
-                <a:latin typeface="Aptos"/>
-                <a:ea typeface="Yu Gothic"/>
+                <a:latin typeface="Noto Sans JP"/>
+                <a:ea typeface="Noto Sans JP"/>
               </a:rPr>
               <a:t>FrontAgent</a:t>
             </a:r>
@@ -8164,8 +8164,8 @@
                 <a:solidFill>
                   <a:srgbClr val="414242"/>
                 </a:solidFill>
-                <a:latin typeface="Aptos"/>
-                <a:ea typeface="Yu Gothic"/>
+                <a:latin typeface="Noto Sans JP"/>
+                <a:ea typeface="Noto Sans JP"/>
               </a:rPr>
               <a:t>2つのプランで、価格感度とkintone連携を分ける</a:t>
             </a:r>
@@ -8259,8 +8259,8 @@
                 <a:solidFill>
                   <a:srgbClr val="6D7375"/>
                 </a:solidFill>
-                <a:latin typeface="Aptos"/>
-                <a:ea typeface="Yu Gothic"/>
+                <a:latin typeface="Noto Sans JP"/>
+                <a:ea typeface="Noto Sans JP"/>
               </a:rPr>
               <a:t>Log Liteは価格アンカー、本命はkintone Packで売る</a:t>
             </a:r>
@@ -8296,8 +8296,8 @@
                 <a:solidFill>
                   <a:srgbClr val="6D7375"/>
                 </a:solidFill>
-                <a:latin typeface="Aptos"/>
-                <a:ea typeface="Yu Gothic"/>
+                <a:latin typeface="Noto Sans JP"/>
+                <a:ea typeface="Noto Sans JP"/>
               </a:rPr>
               <a:t>05</a:t>
             </a:r>
@@ -8337,7 +8337,7 @@
                 <a:solidFill>
                   <a:srgbClr val="FF7143"/>
                 </a:solidFill>
-                <a:ea typeface="Yu Gothic"/>
+                <a:ea typeface="Noto Sans JP"/>
               </a:rPr>
               <a:t/>
             </a:r>
@@ -8431,7 +8431,7 @@
                 <a:solidFill>
                   <a:srgbClr val="FFFFFF"/>
                 </a:solidFill>
-                <a:ea typeface="Yu Gothic"/>
+                <a:ea typeface="Noto Sans JP"/>
               </a:rPr>
               <a:t>ID</a:t>
             </a:r>
@@ -8467,8 +8467,8 @@
                 <a:solidFill>
                   <a:srgbClr val="414242"/>
                 </a:solidFill>
-                <a:latin typeface="Aptos"/>
-                <a:ea typeface="Yu Gothic"/>
+                <a:latin typeface="Noto Sans JP"/>
+                <a:ea typeface="Noto Sans JP"/>
               </a:rPr>
               <a:t>1ID限定 980円/月</a:t>
             </a:r>
@@ -8504,8 +8504,8 @@
                 <a:solidFill>
                   <a:srgbClr val="6D7375"/>
                 </a:solidFill>
-                <a:latin typeface="Aptos"/>
-                <a:ea typeface="Yu Gothic"/>
+                <a:latin typeface="Noto Sans JP"/>
+                <a:ea typeface="Noto Sans JP"/>
               </a:rPr>
               <a:t>追加ID不可。2ID以上・複数名利用はkintone Packで受ける。</a:t>
             </a:r>
@@ -8574,7 +8574,7 @@
                 <a:solidFill>
                   <a:srgbClr val="FF7143"/>
                 </a:solidFill>
-                <a:ea typeface="Yu Gothic"/>
+                <a:ea typeface="Noto Sans JP"/>
               </a:rPr>
               <a:t>分</a:t>
             </a:r>
@@ -8610,8 +8610,8 @@
                 <a:solidFill>
                   <a:srgbClr val="414242"/>
                 </a:solidFill>
-                <a:latin typeface="Aptos"/>
-                <a:ea typeface="Yu Gothic"/>
+                <a:latin typeface="Noto Sans JP"/>
+                <a:ea typeface="Noto Sans JP"/>
               </a:rPr>
               <a:t>月1,800分 / 1ログ5時間</a:t>
             </a:r>
@@ -8647,8 +8647,8 @@
                 <a:solidFill>
                   <a:srgbClr val="6D7375"/>
                 </a:solidFill>
-                <a:latin typeface="Aptos"/>
-                <a:ea typeface="Yu Gothic"/>
+                <a:latin typeface="Noto Sans JP"/>
+                <a:ea typeface="Noto Sans JP"/>
               </a:rPr>
               <a:t>Notta Premiumと同じ分数・1回上限を置き、Premium比較で見劣りしない設計にする。</a:t>
             </a:r>
@@ -8717,7 +8717,7 @@
                 <a:solidFill>
                   <a:srgbClr val="FF7143"/>
                 </a:solidFill>
-                <a:ea typeface="Yu Gothic"/>
+                <a:ea typeface="Noto Sans JP"/>
               </a:rPr>
               <a:t>AI</a:t>
             </a:r>
@@ -8753,8 +8753,8 @@
                 <a:solidFill>
                   <a:srgbClr val="414242"/>
                 </a:solidFill>
-                <a:latin typeface="Aptos"/>
-                <a:ea typeface="Yu Gothic"/>
+                <a:latin typeface="Noto Sans JP"/>
+                <a:ea typeface="Noto Sans JP"/>
               </a:rPr>
               <a:t>AI要約100回/月</a:t>
             </a:r>
@@ -8790,8 +8790,8 @@
                 <a:solidFill>
                   <a:srgbClr val="6D7375"/>
                 </a:solidFill>
-                <a:latin typeface="Aptos"/>
-                <a:ea typeface="Yu Gothic"/>
+                <a:latin typeface="Noto Sans JP"/>
+                <a:ea typeface="Noto Sans JP"/>
               </a:rPr>
               <a:t>Notta Premiumの要約100回/月に合わせ、要約回数でも見劣りさせない。</a:t>
             </a:r>
@@ -8860,7 +8860,7 @@
                 <a:solidFill>
                   <a:srgbClr val="FF7143"/>
                 </a:solidFill>
-                <a:ea typeface="Yu Gothic"/>
+                <a:ea typeface="Noto Sans JP"/>
               </a:rPr>
               <a:t>止</a:t>
             </a:r>
@@ -8896,8 +8896,8 @@
                 <a:solidFill>
                   <a:srgbClr val="414242"/>
                 </a:solidFill>
-                <a:latin typeface="Aptos"/>
-                <a:ea typeface="Yu Gothic"/>
+                <a:latin typeface="Noto Sans JP"/>
+                <a:ea typeface="Noto Sans JP"/>
               </a:rPr>
               <a:t>上限超過時は停止</a:t>
             </a:r>
@@ -8933,8 +8933,8 @@
                 <a:solidFill>
                   <a:srgbClr val="6D7375"/>
                 </a:solidFill>
-                <a:latin typeface="Aptos"/>
-                <a:ea typeface="Yu Gothic"/>
+                <a:latin typeface="Noto Sans JP"/>
+                <a:ea typeface="Noto Sans JP"/>
               </a:rPr>
               <a:t>追加利用は不可。それ以上使いたい場合はkintone Packへの移管を必須にする。</a:t>
             </a:r>
@@ -8999,8 +8999,8 @@
                 <a:solidFill>
                   <a:srgbClr val="414242"/>
                 </a:solidFill>
-                <a:latin typeface="Aptos"/>
-                <a:ea typeface="Yu Gothic"/>
+                <a:latin typeface="Noto Sans JP"/>
+                <a:ea typeface="Noto Sans JP"/>
               </a:rPr>
               <a:t>Log Lite Usage Cap</a:t>
             </a:r>
@@ -9036,8 +9036,8 @@
                 <a:solidFill>
                   <a:srgbClr val="6D7375"/>
                 </a:solidFill>
-                <a:latin typeface="Aptos"/>
-                <a:ea typeface="Yu Gothic"/>
+                <a:latin typeface="Noto Sans JP"/>
+                <a:ea typeface="Noto Sans JP"/>
               </a:rPr>
               <a:t>1ID限定 / 980円 / 月</a:t>
             </a:r>
@@ -9102,8 +9102,8 @@
                 <a:solidFill>
                   <a:srgbClr val="FF7143"/>
                 </a:solidFill>
-                <a:latin typeface="Aptos"/>
-                <a:ea typeface="Yu Gothic"/>
+                <a:latin typeface="Noto Sans JP"/>
+                <a:ea typeface="Noto Sans JP"/>
               </a:rPr>
               <a:t>1,800</a:t>
             </a:r>
@@ -9139,8 +9139,8 @@
                 <a:solidFill>
                   <a:srgbClr val="414242"/>
                 </a:solidFill>
-                <a:latin typeface="Aptos"/>
-                <a:ea typeface="Yu Gothic"/>
+                <a:latin typeface="Noto Sans JP"/>
+                <a:ea typeface="Noto Sans JP"/>
               </a:rPr>
               <a:t>分 / 月</a:t>
             </a:r>
@@ -9234,8 +9234,8 @@
                 <a:solidFill>
                   <a:srgbClr val="6D7375"/>
                 </a:solidFill>
-                <a:latin typeface="Aptos"/>
-                <a:ea typeface="Yu Gothic"/>
+                <a:latin typeface="Noto Sans JP"/>
+                <a:ea typeface="Noto Sans JP"/>
               </a:rPr>
               <a:t>Premium基準</a:t>
             </a:r>
@@ -9300,8 +9300,8 @@
                 <a:solidFill>
                   <a:srgbClr val="FF7143"/>
                 </a:solidFill>
-                <a:latin typeface="Aptos"/>
-                <a:ea typeface="Yu Gothic"/>
+                <a:latin typeface="Noto Sans JP"/>
+                <a:ea typeface="Noto Sans JP"/>
               </a:rPr>
               <a:t>5h</a:t>
             </a:r>
@@ -9337,8 +9337,8 @@
                 <a:solidFill>
                   <a:srgbClr val="414242"/>
                 </a:solidFill>
-                <a:latin typeface="Aptos"/>
-                <a:ea typeface="Yu Gothic"/>
+                <a:latin typeface="Noto Sans JP"/>
+                <a:ea typeface="Noto Sans JP"/>
               </a:rPr>
               <a:t>/ ログ</a:t>
             </a:r>
@@ -9432,8 +9432,8 @@
                 <a:solidFill>
                   <a:srgbClr val="6D7375"/>
                 </a:solidFill>
-                <a:latin typeface="Aptos"/>
-                <a:ea typeface="Yu Gothic"/>
+                <a:latin typeface="Noto Sans JP"/>
+                <a:ea typeface="Noto Sans JP"/>
               </a:rPr>
               <a:t>1回上限</a:t>
             </a:r>
@@ -9498,8 +9498,8 @@
                 <a:solidFill>
                   <a:srgbClr val="FF7143"/>
                 </a:solidFill>
-                <a:latin typeface="Aptos"/>
-                <a:ea typeface="Yu Gothic"/>
+                <a:latin typeface="Noto Sans JP"/>
+                <a:ea typeface="Noto Sans JP"/>
               </a:rPr>
               <a:t>100</a:t>
             </a:r>
@@ -9535,8 +9535,8 @@
                 <a:solidFill>
                   <a:srgbClr val="414242"/>
                 </a:solidFill>
-                <a:latin typeface="Aptos"/>
-                <a:ea typeface="Yu Gothic"/>
+                <a:latin typeface="Noto Sans JP"/>
+                <a:ea typeface="Noto Sans JP"/>
               </a:rPr>
               <a:t>AI要約</a:t>
             </a:r>
@@ -9630,8 +9630,8 @@
                 <a:solidFill>
                   <a:srgbClr val="6D7375"/>
                 </a:solidFill>
-                <a:latin typeface="Aptos"/>
-                <a:ea typeface="Yu Gothic"/>
+                <a:latin typeface="Noto Sans JP"/>
+                <a:ea typeface="Noto Sans JP"/>
               </a:rPr>
               <a:t>要約100回/月</a:t>
             </a:r>
@@ -9696,8 +9696,8 @@
                 <a:solidFill>
                   <a:srgbClr val="414242"/>
                 </a:solidFill>
-                <a:latin typeface="Aptos"/>
-                <a:ea typeface="Yu Gothic"/>
+                <a:latin typeface="Noto Sans JP"/>
+                <a:ea typeface="Noto Sans JP"/>
               </a:rPr>
               <a:t>上限超過時は停止 / 継続利用は kintone Pack 移管必須</a:t>
             </a:r>
@@ -9762,8 +9762,8 @@
                 <a:solidFill>
                   <a:srgbClr val="6D7375"/>
                 </a:solidFill>
-                <a:latin typeface="Aptos"/>
-                <a:ea typeface="Yu Gothic"/>
+                <a:latin typeface="Noto Sans JP"/>
+                <a:ea typeface="Noto Sans JP"/>
               </a:rPr>
               <a:t>Log Lite</a:t>
             </a:r>
@@ -9799,8 +9799,8 @@
                 <a:solidFill>
                   <a:srgbClr val="414242"/>
                 </a:solidFill>
-                <a:latin typeface="Aptos"/>
-                <a:ea typeface="Yu Gothic"/>
+                <a:latin typeface="Noto Sans JP"/>
+                <a:ea typeface="Noto Sans JP"/>
               </a:rPr>
               <a:t>FrontAgent</a:t>
             </a:r>
@@ -9836,8 +9836,8 @@
                 <a:solidFill>
                   <a:srgbClr val="414242"/>
                 </a:solidFill>
-                <a:latin typeface="Aptos"/>
-                <a:ea typeface="Yu Gothic"/>
+                <a:latin typeface="Noto Sans JP"/>
+                <a:ea typeface="Noto Sans JP"/>
               </a:rPr>
               <a:t>Log Liteは、Notta Premium基準の利用上限に寄せる</a:t>
             </a:r>
@@ -9931,8 +9931,8 @@
                 <a:solidFill>
                   <a:srgbClr val="6D7375"/>
                 </a:solidFill>
-                <a:latin typeface="Aptos"/>
-                <a:ea typeface="Yu Gothic"/>
+                <a:latin typeface="Noto Sans JP"/>
+                <a:ea typeface="Noto Sans JP"/>
               </a:rPr>
               <a:t>Notta Premium基準の上限で、価格アンカーとして扱う</a:t>
             </a:r>
@@ -9968,8 +9968,8 @@
                 <a:solidFill>
                   <a:srgbClr val="6D7375"/>
                 </a:solidFill>
-                <a:latin typeface="Aptos"/>
-                <a:ea typeface="Yu Gothic"/>
+                <a:latin typeface="Noto Sans JP"/>
+                <a:ea typeface="Noto Sans JP"/>
               </a:rPr>
               <a:t>06</a:t>
             </a:r>
@@ -10009,7 +10009,7 @@
                 <a:solidFill>
                   <a:srgbClr val="FF7143"/>
                 </a:solidFill>
-                <a:ea typeface="Yu Gothic"/>
+                <a:ea typeface="Noto Sans JP"/>
               </a:rPr>
               <a:t/>
             </a:r>
@@ -10101,8 +10101,8 @@
                 <a:solidFill>
                   <a:srgbClr val="FF7143"/>
                 </a:solidFill>
-                <a:latin typeface="Aptos"/>
-                <a:ea typeface="Yu Gothic"/>
+                <a:latin typeface="Noto Sans JP"/>
+                <a:ea typeface="Noto Sans JP"/>
               </a:rPr>
               <a:t>初年度限定</a:t>
             </a:r>
@@ -10138,8 +10138,8 @@
                 <a:solidFill>
                   <a:srgbClr val="FF7143"/>
                 </a:solidFill>
-                <a:latin typeface="Aptos"/>
-                <a:ea typeface="Yu Gothic"/>
+                <a:latin typeface="Noto Sans JP"/>
+                <a:ea typeface="Noto Sans JP"/>
               </a:rPr>
               <a:t>2,980円/ID/月</a:t>
             </a:r>
@@ -10204,8 +10204,8 @@
                 <a:solidFill>
                   <a:srgbClr val="414242"/>
                 </a:solidFill>
-                <a:latin typeface="Aptos"/>
-                <a:ea typeface="Yu Gothic"/>
+                <a:latin typeface="Noto Sans JP"/>
+                <a:ea typeface="Noto Sans JP"/>
               </a:rPr>
               <a:t>対象 契約開始から12ヶ月</a:t>
             </a:r>
@@ -10270,8 +10270,8 @@
                 <a:solidFill>
                   <a:srgbClr val="414242"/>
                 </a:solidFill>
-                <a:latin typeface="Aptos"/>
-                <a:ea typeface="Yu Gothic"/>
+                <a:latin typeface="Noto Sans JP"/>
+                <a:ea typeface="Noto Sans JP"/>
               </a:rPr>
               <a:t>対象外 LogLiteからの移管</a:t>
             </a:r>
@@ -10336,8 +10336,8 @@
                 <a:solidFill>
                   <a:srgbClr val="414242"/>
                 </a:solidFill>
-                <a:latin typeface="Aptos"/>
-                <a:ea typeface="Yu Gothic"/>
+                <a:latin typeface="Noto Sans JP"/>
+                <a:ea typeface="Noto Sans JP"/>
               </a:rPr>
               <a:t>ID 2ID以上・追加IDはこちら</a:t>
             </a:r>
@@ -10402,8 +10402,8 @@
                 <a:solidFill>
                   <a:srgbClr val="6D7375"/>
                 </a:solidFill>
-                <a:latin typeface="Aptos"/>
-                <a:ea typeface="Yu Gothic"/>
+                <a:latin typeface="Noto Sans JP"/>
+                <a:ea typeface="Noto Sans JP"/>
               </a:rPr>
               <a:t>2年目以降 通常5,980円/ID/月</a:t>
             </a:r>
@@ -10468,8 +10468,8 @@
                 <a:solidFill>
                   <a:srgbClr val="414242"/>
                 </a:solidFill>
-                <a:latin typeface="Aptos"/>
-                <a:ea typeface="Yu Gothic"/>
+                <a:latin typeface="Noto Sans JP"/>
+                <a:ea typeface="Noto Sans JP"/>
               </a:rPr>
               <a:t>項目</a:t>
             </a:r>
@@ -10534,8 +10534,8 @@
                 <a:solidFill>
                   <a:srgbClr val="414242"/>
                 </a:solidFill>
-                <a:latin typeface="Aptos"/>
-                <a:ea typeface="Yu Gothic"/>
+                <a:latin typeface="Noto Sans JP"/>
+                <a:ea typeface="Noto Sans JP"/>
               </a:rPr>
               <a:t>通常</a:t>
             </a:r>
@@ -10600,8 +10600,8 @@
                 <a:solidFill>
                   <a:srgbClr val="414242"/>
                 </a:solidFill>
-                <a:latin typeface="Aptos"/>
-                <a:ea typeface="Yu Gothic"/>
+                <a:latin typeface="Noto Sans JP"/>
+                <a:ea typeface="Noto Sans JP"/>
               </a:rPr>
               <a:t>初年度限定</a:t>
             </a:r>
@@ -10666,8 +10666,8 @@
                 <a:solidFill>
                   <a:srgbClr val="414242"/>
                 </a:solidFill>
-                <a:latin typeface="Aptos"/>
-                <a:ea typeface="Yu Gothic"/>
+                <a:latin typeface="Noto Sans JP"/>
+                <a:ea typeface="Noto Sans JP"/>
               </a:rPr>
               <a:t>ID単価</a:t>
             </a:r>
@@ -10732,8 +10732,8 @@
                 <a:solidFill>
                   <a:srgbClr val="6D7375"/>
                 </a:solidFill>
-                <a:latin typeface="Aptos"/>
-                <a:ea typeface="Yu Gothic"/>
+                <a:latin typeface="Noto Sans JP"/>
+                <a:ea typeface="Noto Sans JP"/>
               </a:rPr>
               <a:t>5,980円 / ID / 月</a:t>
             </a:r>
@@ -10798,8 +10798,8 @@
                 <a:solidFill>
                   <a:srgbClr val="6D7375"/>
                 </a:solidFill>
-                <a:latin typeface="Aptos"/>
-                <a:ea typeface="Yu Gothic"/>
+                <a:latin typeface="Noto Sans JP"/>
+                <a:ea typeface="Noto Sans JP"/>
               </a:rPr>
               <a:t>2,980円 / ID / 月</a:t>
             </a:r>
@@ -10864,8 +10864,8 @@
                 <a:solidFill>
                   <a:srgbClr val="414242"/>
                 </a:solidFill>
-                <a:latin typeface="Aptos"/>
-                <a:ea typeface="Yu Gothic"/>
+                <a:latin typeface="Noto Sans JP"/>
+                <a:ea typeface="Noto Sans JP"/>
               </a:rPr>
               <a:t>最小契約</a:t>
             </a:r>
@@ -10930,8 +10930,8 @@
                 <a:solidFill>
                   <a:srgbClr val="6D7375"/>
                 </a:solidFill>
-                <a:latin typeface="Aptos"/>
-                <a:ea typeface="Yu Gothic"/>
+                <a:latin typeface="Noto Sans JP"/>
+                <a:ea typeface="Noto Sans JP"/>
               </a:rPr>
               <a:t>1ID</a:t>
             </a:r>
@@ -10996,8 +10996,8 @@
                 <a:solidFill>
                   <a:srgbClr val="6D7375"/>
                 </a:solidFill>
-                <a:latin typeface="Aptos"/>
-                <a:ea typeface="Yu Gothic"/>
+                <a:latin typeface="Noto Sans JP"/>
+                <a:ea typeface="Noto Sans JP"/>
               </a:rPr>
               <a:t>1ID</a:t>
             </a:r>
@@ -11062,8 +11062,8 @@
                 <a:solidFill>
                   <a:srgbClr val="414242"/>
                 </a:solidFill>
-                <a:latin typeface="Aptos"/>
-                <a:ea typeface="Yu Gothic"/>
+                <a:latin typeface="Noto Sans JP"/>
+                <a:ea typeface="Noto Sans JP"/>
               </a:rPr>
               <a:t>初期費用</a:t>
             </a:r>
@@ -11128,8 +11128,8 @@
                 <a:solidFill>
                   <a:srgbClr val="6D7375"/>
                 </a:solidFill>
-                <a:latin typeface="Aptos"/>
-                <a:ea typeface="Yu Gothic"/>
+                <a:latin typeface="Noto Sans JP"/>
+                <a:ea typeface="Noto Sans JP"/>
               </a:rPr>
               <a:t>0円</a:t>
             </a:r>
@@ -11194,8 +11194,8 @@
                 <a:solidFill>
                   <a:srgbClr val="6D7375"/>
                 </a:solidFill>
-                <a:latin typeface="Aptos"/>
-                <a:ea typeface="Yu Gothic"/>
+                <a:latin typeface="Noto Sans JP"/>
+                <a:ea typeface="Noto Sans JP"/>
               </a:rPr>
               <a:t>0円</a:t>
             </a:r>
@@ -11260,8 +11260,8 @@
                 <a:solidFill>
                   <a:srgbClr val="414242"/>
                 </a:solidFill>
-                <a:latin typeface="Aptos"/>
-                <a:ea typeface="Yu Gothic"/>
+                <a:latin typeface="Noto Sans JP"/>
+                <a:ea typeface="Noto Sans JP"/>
               </a:rPr>
               <a:t>契約期間</a:t>
             </a:r>
@@ -11326,8 +11326,8 @@
                 <a:solidFill>
                   <a:srgbClr val="6D7375"/>
                 </a:solidFill>
-                <a:latin typeface="Aptos"/>
-                <a:ea typeface="Yu Gothic"/>
+                <a:latin typeface="Noto Sans JP"/>
+                <a:ea typeface="Noto Sans JP"/>
               </a:rPr>
               <a:t>12ヶ月</a:t>
             </a:r>
@@ -11392,8 +11392,8 @@
                 <a:solidFill>
                   <a:srgbClr val="6D7375"/>
                 </a:solidFill>
-                <a:latin typeface="Aptos"/>
-                <a:ea typeface="Yu Gothic"/>
+                <a:latin typeface="Noto Sans JP"/>
+                <a:ea typeface="Noto Sans JP"/>
               </a:rPr>
               <a:t>初年度12ヶ月</a:t>
             </a:r>
@@ -11458,8 +11458,8 @@
                 <a:solidFill>
                   <a:srgbClr val="414242"/>
                 </a:solidFill>
-                <a:latin typeface="Aptos"/>
-                <a:ea typeface="Yu Gothic"/>
+                <a:latin typeface="Noto Sans JP"/>
+                <a:ea typeface="Noto Sans JP"/>
               </a:rPr>
               <a:t>適用条件</a:t>
             </a:r>
@@ -11524,8 +11524,8 @@
                 <a:solidFill>
                   <a:srgbClr val="6D7375"/>
                 </a:solidFill>
-                <a:latin typeface="Aptos"/>
-                <a:ea typeface="Yu Gothic"/>
+                <a:latin typeface="Noto Sans JP"/>
+                <a:ea typeface="Noto Sans JP"/>
               </a:rPr>
               <a:t>継続・移管時はこちら</a:t>
             </a:r>
@@ -11590,8 +11590,8 @@
                 <a:solidFill>
                   <a:srgbClr val="6D7375"/>
                 </a:solidFill>
-                <a:latin typeface="Aptos"/>
-                <a:ea typeface="Yu Gothic"/>
+                <a:latin typeface="Noto Sans JP"/>
+                <a:ea typeface="Noto Sans JP"/>
               </a:rPr>
               <a:t>初年度のみ。（LogLiteからの移管は対象外）</a:t>
             </a:r>
@@ -11683,8 +11683,8 @@
                 <a:solidFill>
                   <a:srgbClr val="6D7375"/>
                 </a:solidFill>
-                <a:latin typeface="Aptos"/>
-                <a:ea typeface="Yu Gothic"/>
+                <a:latin typeface="Noto Sans JP"/>
+                <a:ea typeface="Noto Sans JP"/>
               </a:rPr>
               <a:t>kintone Pack Price</a:t>
             </a:r>
@@ -11720,8 +11720,8 @@
                 <a:solidFill>
                   <a:srgbClr val="414242"/>
                 </a:solidFill>
-                <a:latin typeface="Aptos"/>
-                <a:ea typeface="Yu Gothic"/>
+                <a:latin typeface="Noto Sans JP"/>
+                <a:ea typeface="Noto Sans JP"/>
               </a:rPr>
               <a:t>FrontAgent</a:t>
             </a:r>
@@ -11757,8 +11757,8 @@
                 <a:solidFill>
                   <a:srgbClr val="414242"/>
                 </a:solidFill>
-                <a:latin typeface="Aptos"/>
-                <a:ea typeface="Yu Gothic"/>
+                <a:latin typeface="Noto Sans JP"/>
+                <a:ea typeface="Noto Sans JP"/>
               </a:rPr>
               <a:t>kintone Packは、1IDから追加IDまで同じ単価で積み上げる</a:t>
             </a:r>
@@ -11852,8 +11852,8 @@
                 <a:solidFill>
                   <a:srgbClr val="6D7375"/>
                 </a:solidFill>
-                <a:latin typeface="Aptos"/>
-                <a:ea typeface="Yu Gothic"/>
+                <a:latin typeface="Noto Sans JP"/>
+                <a:ea typeface="Noto Sans JP"/>
               </a:rPr>
               <a:t>1ID開始で見た目の価格を下げ、年契約で稼働を担保する</a:t>
             </a:r>
@@ -11889,8 +11889,8 @@
                 <a:solidFill>
                   <a:srgbClr val="6D7375"/>
                 </a:solidFill>
-                <a:latin typeface="Aptos"/>
-                <a:ea typeface="Yu Gothic"/>
+                <a:latin typeface="Noto Sans JP"/>
+                <a:ea typeface="Noto Sans JP"/>
               </a:rPr>
               <a:t>07</a:t>
             </a:r>
@@ -11930,7 +11930,7 @@
                 <a:solidFill>
                   <a:srgbClr val="FF7143"/>
                 </a:solidFill>
-                <a:ea typeface="Yu Gothic"/>
+                <a:ea typeface="Noto Sans JP"/>
               </a:rPr>
               <a:t/>
             </a:r>
@@ -12020,8 +12020,8 @@
                 <a:solidFill>
                   <a:srgbClr val="414242"/>
                 </a:solidFill>
-                <a:latin typeface="Aptos"/>
-                <a:ea typeface="Yu Gothic"/>
+                <a:latin typeface="Noto Sans JP"/>
+                <a:ea typeface="Noto Sans JP"/>
               </a:rPr>
               <a:t>利用ID数</a:t>
             </a:r>
@@ -12086,8 +12086,8 @@
                 <a:solidFill>
                   <a:srgbClr val="414242"/>
                 </a:solidFill>
-                <a:latin typeface="Aptos"/>
-                <a:ea typeface="Yu Gothic"/>
+                <a:latin typeface="Noto Sans JP"/>
+                <a:ea typeface="Noto Sans JP"/>
               </a:rPr>
               <a:t>通常月額</a:t>
             </a:r>
@@ -12152,8 +12152,8 @@
                 <a:solidFill>
                   <a:srgbClr val="414242"/>
                 </a:solidFill>
-                <a:latin typeface="Aptos"/>
-                <a:ea typeface="Yu Gothic"/>
+                <a:latin typeface="Noto Sans JP"/>
+                <a:ea typeface="Noto Sans JP"/>
               </a:rPr>
               <a:t>初年度限定月額</a:t>
             </a:r>
@@ -12218,8 +12218,8 @@
                 <a:solidFill>
                   <a:srgbClr val="414242"/>
                 </a:solidFill>
-                <a:latin typeface="Aptos"/>
-                <a:ea typeface="Yu Gothic"/>
+                <a:latin typeface="Noto Sans JP"/>
+                <a:ea typeface="Noto Sans JP"/>
               </a:rPr>
               <a:t>考え方</a:t>
             </a:r>
@@ -12284,8 +12284,8 @@
                 <a:solidFill>
                   <a:srgbClr val="414242"/>
                 </a:solidFill>
-                <a:latin typeface="Aptos"/>
-                <a:ea typeface="Yu Gothic"/>
+                <a:latin typeface="Noto Sans JP"/>
+                <a:ea typeface="Noto Sans JP"/>
               </a:rPr>
               <a:t>1ID</a:t>
             </a:r>
@@ -12350,8 +12350,8 @@
                 <a:solidFill>
                   <a:srgbClr val="6D7375"/>
                 </a:solidFill>
-                <a:latin typeface="Aptos"/>
-                <a:ea typeface="Yu Gothic"/>
+                <a:latin typeface="Noto Sans JP"/>
+                <a:ea typeface="Noto Sans JP"/>
               </a:rPr>
               <a:t>5,980円</a:t>
             </a:r>
@@ -12416,8 +12416,8 @@
                 <a:solidFill>
                   <a:srgbClr val="6D7375"/>
                 </a:solidFill>
-                <a:latin typeface="Aptos"/>
-                <a:ea typeface="Yu Gothic"/>
+                <a:latin typeface="Noto Sans JP"/>
+                <a:ea typeface="Noto Sans JP"/>
               </a:rPr>
               <a:t>2,980円</a:t>
             </a:r>
@@ -12482,8 +12482,8 @@
                 <a:solidFill>
                   <a:srgbClr val="6D7375"/>
                 </a:solidFill>
-                <a:latin typeface="Aptos"/>
-                <a:ea typeface="Yu Gothic"/>
+                <a:latin typeface="Noto Sans JP"/>
+                <a:ea typeface="Noto Sans JP"/>
               </a:rPr>
               <a:t>Packの最小契約</a:t>
             </a:r>
@@ -12548,8 +12548,8 @@
                 <a:solidFill>
                   <a:srgbClr val="414242"/>
                 </a:solidFill>
-                <a:latin typeface="Aptos"/>
-                <a:ea typeface="Yu Gothic"/>
+                <a:latin typeface="Noto Sans JP"/>
+                <a:ea typeface="Noto Sans JP"/>
               </a:rPr>
               <a:t>2ID</a:t>
             </a:r>
@@ -12614,8 +12614,8 @@
                 <a:solidFill>
                   <a:srgbClr val="6D7375"/>
                 </a:solidFill>
-                <a:latin typeface="Aptos"/>
-                <a:ea typeface="Yu Gothic"/>
+                <a:latin typeface="Noto Sans JP"/>
+                <a:ea typeface="Noto Sans JP"/>
               </a:rPr>
               <a:t>11,960円</a:t>
             </a:r>
@@ -12680,8 +12680,8 @@
                 <a:solidFill>
                   <a:srgbClr val="6D7375"/>
                 </a:solidFill>
-                <a:latin typeface="Aptos"/>
-                <a:ea typeface="Yu Gothic"/>
+                <a:latin typeface="Noto Sans JP"/>
+                <a:ea typeface="Noto Sans JP"/>
               </a:rPr>
               <a:t>5,960円</a:t>
             </a:r>
@@ -12746,8 +12746,8 @@
                 <a:solidFill>
                   <a:srgbClr val="6D7375"/>
                 </a:solidFill>
-                <a:latin typeface="Aptos"/>
-                <a:ea typeface="Yu Gothic"/>
+                <a:latin typeface="Noto Sans JP"/>
+                <a:ea typeface="Noto Sans JP"/>
               </a:rPr>
               <a:t>LiteではなくPack</a:t>
             </a:r>
@@ -12812,8 +12812,8 @@
                 <a:solidFill>
                   <a:srgbClr val="414242"/>
                 </a:solidFill>
-                <a:latin typeface="Aptos"/>
-                <a:ea typeface="Yu Gothic"/>
+                <a:latin typeface="Noto Sans JP"/>
+                <a:ea typeface="Noto Sans JP"/>
               </a:rPr>
               <a:t>5ID</a:t>
             </a:r>
@@ -12878,8 +12878,8 @@
                 <a:solidFill>
                   <a:srgbClr val="6D7375"/>
                 </a:solidFill>
-                <a:latin typeface="Aptos"/>
-                <a:ea typeface="Yu Gothic"/>
+                <a:latin typeface="Noto Sans JP"/>
+                <a:ea typeface="Noto Sans JP"/>
               </a:rPr>
               <a:t>29,900円</a:t>
             </a:r>
@@ -12944,8 +12944,8 @@
                 <a:solidFill>
                   <a:srgbClr val="6D7375"/>
                 </a:solidFill>
-                <a:latin typeface="Aptos"/>
-                <a:ea typeface="Yu Gothic"/>
+                <a:latin typeface="Noto Sans JP"/>
+                <a:ea typeface="Noto Sans JP"/>
               </a:rPr>
               <a:t>14,900円</a:t>
             </a:r>
@@ -13010,8 +13010,8 @@
                 <a:solidFill>
                   <a:srgbClr val="6D7375"/>
                 </a:solidFill>
-                <a:latin typeface="Aptos"/>
-                <a:ea typeface="Yu Gothic"/>
+                <a:latin typeface="Noto Sans JP"/>
+                <a:ea typeface="Noto Sans JP"/>
               </a:rPr>
               <a:t>部門利用</a:t>
             </a:r>
@@ -13076,8 +13076,8 @@
                 <a:solidFill>
                   <a:srgbClr val="414242"/>
                 </a:solidFill>
-                <a:latin typeface="Aptos"/>
-                <a:ea typeface="Yu Gothic"/>
+                <a:latin typeface="Noto Sans JP"/>
+                <a:ea typeface="Noto Sans JP"/>
               </a:rPr>
               <a:t>10ID</a:t>
             </a:r>
@@ -13142,8 +13142,8 @@
                 <a:solidFill>
                   <a:srgbClr val="6D7375"/>
                 </a:solidFill>
-                <a:latin typeface="Aptos"/>
-                <a:ea typeface="Yu Gothic"/>
+                <a:latin typeface="Noto Sans JP"/>
+                <a:ea typeface="Noto Sans JP"/>
               </a:rPr>
               <a:t>59,800円</a:t>
             </a:r>
@@ -13208,8 +13208,8 @@
                 <a:solidFill>
                   <a:srgbClr val="6D7375"/>
                 </a:solidFill>
-                <a:latin typeface="Aptos"/>
-                <a:ea typeface="Yu Gothic"/>
+                <a:latin typeface="Noto Sans JP"/>
+                <a:ea typeface="Noto Sans JP"/>
               </a:rPr>
               <a:t>29,800円</a:t>
             </a:r>
@@ -13274,8 +13274,8 @@
                 <a:solidFill>
                   <a:srgbClr val="6D7375"/>
                 </a:solidFill>
-                <a:latin typeface="Aptos"/>
-                <a:ea typeface="Yu Gothic"/>
+                <a:latin typeface="Noto Sans JP"/>
+                <a:ea typeface="Noto Sans JP"/>
               </a:rPr>
               <a:t>複数部門展開</a:t>
             </a:r>
@@ -13367,8 +13367,8 @@
                 <a:solidFill>
                   <a:srgbClr val="414242"/>
                 </a:solidFill>
-                <a:latin typeface="Aptos"/>
-                <a:ea typeface="Yu Gothic"/>
+                <a:latin typeface="Noto Sans JP"/>
+                <a:ea typeface="Noto Sans JP"/>
               </a:rPr>
               <a:t>ID Pricing Ladder</a:t>
             </a:r>
@@ -13433,8 +13433,8 @@
                 <a:solidFill>
                   <a:srgbClr val="414242"/>
                 </a:solidFill>
-                <a:latin typeface="Aptos"/>
-                <a:ea typeface="Yu Gothic"/>
+                <a:latin typeface="Noto Sans JP"/>
+                <a:ea typeface="Noto Sans JP"/>
               </a:rPr>
               <a:t>1ID</a:t>
             </a:r>
@@ -13470,8 +13470,8 @@
                 <a:solidFill>
                   <a:srgbClr val="FFFFFF"/>
                 </a:solidFill>
-                <a:latin typeface="Aptos"/>
-                <a:ea typeface="Yu Gothic"/>
+                <a:latin typeface="Noto Sans JP"/>
+                <a:ea typeface="Noto Sans JP"/>
               </a:rPr>
               <a:t>2,980</a:t>
             </a:r>
@@ -13536,8 +13536,8 @@
                 <a:solidFill>
                   <a:srgbClr val="414242"/>
                 </a:solidFill>
-                <a:latin typeface="Aptos"/>
-                <a:ea typeface="Yu Gothic"/>
+                <a:latin typeface="Noto Sans JP"/>
+                <a:ea typeface="Noto Sans JP"/>
               </a:rPr>
               <a:t>2ID</a:t>
             </a:r>
@@ -13573,8 +13573,8 @@
                 <a:solidFill>
                   <a:srgbClr val="FFFFFF"/>
                 </a:solidFill>
-                <a:latin typeface="Aptos"/>
-                <a:ea typeface="Yu Gothic"/>
+                <a:latin typeface="Noto Sans JP"/>
+                <a:ea typeface="Noto Sans JP"/>
               </a:rPr>
               <a:t>5,960</a:t>
             </a:r>
@@ -13639,8 +13639,8 @@
                 <a:solidFill>
                   <a:srgbClr val="414242"/>
                 </a:solidFill>
-                <a:latin typeface="Aptos"/>
-                <a:ea typeface="Yu Gothic"/>
+                <a:latin typeface="Noto Sans JP"/>
+                <a:ea typeface="Noto Sans JP"/>
               </a:rPr>
               <a:t>5ID</a:t>
             </a:r>
@@ -13676,8 +13676,8 @@
                 <a:solidFill>
                   <a:srgbClr val="FFFFFF"/>
                 </a:solidFill>
-                <a:latin typeface="Aptos"/>
-                <a:ea typeface="Yu Gothic"/>
+                <a:latin typeface="Noto Sans JP"/>
+                <a:ea typeface="Noto Sans JP"/>
               </a:rPr>
               <a:t>14,900</a:t>
             </a:r>
@@ -13742,8 +13742,8 @@
                 <a:solidFill>
                   <a:srgbClr val="414242"/>
                 </a:solidFill>
-                <a:latin typeface="Aptos"/>
-                <a:ea typeface="Yu Gothic"/>
+                <a:latin typeface="Noto Sans JP"/>
+                <a:ea typeface="Noto Sans JP"/>
               </a:rPr>
               <a:t>10ID</a:t>
             </a:r>
@@ -13779,8 +13779,8 @@
                 <a:solidFill>
                   <a:srgbClr val="FFFFFF"/>
                 </a:solidFill>
-                <a:latin typeface="Aptos"/>
-                <a:ea typeface="Yu Gothic"/>
+                <a:latin typeface="Noto Sans JP"/>
+                <a:ea typeface="Noto Sans JP"/>
               </a:rPr>
               <a:t>29,800</a:t>
             </a:r>
@@ -13874,8 +13874,8 @@
                 <a:solidFill>
                   <a:srgbClr val="6D7375"/>
                 </a:solidFill>
-                <a:latin typeface="Aptos"/>
-                <a:ea typeface="Yu Gothic"/>
+                <a:latin typeface="Noto Sans JP"/>
+                <a:ea typeface="Noto Sans JP"/>
               </a:rPr>
               <a:t>ID Pricing</a:t>
             </a:r>
@@ -13911,8 +13911,8 @@
                 <a:solidFill>
                   <a:srgbClr val="414242"/>
                 </a:solidFill>
-                <a:latin typeface="Aptos"/>
-                <a:ea typeface="Yu Gothic"/>
+                <a:latin typeface="Noto Sans JP"/>
+                <a:ea typeface="Noto Sans JP"/>
               </a:rPr>
               <a:t>FrontAgent</a:t>
             </a:r>
@@ -13948,8 +13948,8 @@
                 <a:solidFill>
                   <a:srgbClr val="414242"/>
                 </a:solidFill>
-                <a:latin typeface="Aptos"/>
-                <a:ea typeface="Yu Gothic"/>
+                <a:latin typeface="Noto Sans JP"/>
+                <a:ea typeface="Noto Sans JP"/>
               </a:rPr>
               <a:t>2ID以上・追加IDはkintone Packで同じ単価を積み上げる</a:t>
             </a:r>
@@ -14043,8 +14043,8 @@
                 <a:solidFill>
                   <a:srgbClr val="6D7375"/>
                 </a:solidFill>
-                <a:latin typeface="Aptos"/>
-                <a:ea typeface="Yu Gothic"/>
+                <a:latin typeface="Noto Sans JP"/>
+                <a:ea typeface="Noto Sans JP"/>
               </a:rPr>
               <a:t>初年度のみ2,980円/ID。2年目以降は通常5,980円/ID</a:t>
             </a:r>
@@ -14080,8 +14080,8 @@
                 <a:solidFill>
                   <a:srgbClr val="6D7375"/>
                 </a:solidFill>
-                <a:latin typeface="Aptos"/>
-                <a:ea typeface="Yu Gothic"/>
+                <a:latin typeface="Noto Sans JP"/>
+                <a:ea typeface="Noto Sans JP"/>
               </a:rPr>
               <a:t>08</a:t>
             </a:r>
@@ -14121,7 +14121,7 @@
                 <a:solidFill>
                   <a:srgbClr val="FF7143"/>
                 </a:solidFill>
-                <a:ea typeface="Yu Gothic"/>
+                <a:ea typeface="Noto Sans JP"/>
               </a:rPr>
               <a:t/>
             </a:r>
@@ -14211,8 +14211,8 @@
                 <a:solidFill>
                   <a:srgbClr val="414242"/>
                 </a:solidFill>
-                <a:latin typeface="Aptos"/>
-                <a:ea typeface="Yu Gothic"/>
+                <a:latin typeface="Noto Sans JP"/>
+                <a:ea typeface="Noto Sans JP"/>
               </a:rPr>
               <a:t>カテゴリ</a:t>
             </a:r>
@@ -14277,8 +14277,8 @@
                 <a:solidFill>
                   <a:srgbClr val="414242"/>
                 </a:solidFill>
-                <a:latin typeface="Aptos"/>
-                <a:ea typeface="Yu Gothic"/>
+                <a:latin typeface="Noto Sans JP"/>
+                <a:ea typeface="Noto Sans JP"/>
               </a:rPr>
               <a:t>代表例</a:t>
             </a:r>
@@ -14343,8 +14343,8 @@
                 <a:solidFill>
                   <a:srgbClr val="414242"/>
                 </a:solidFill>
-                <a:latin typeface="Aptos"/>
-                <a:ea typeface="Yu Gothic"/>
+                <a:latin typeface="Noto Sans JP"/>
+                <a:ea typeface="Noto Sans JP"/>
               </a:rPr>
               <a:t>価格感覚</a:t>
             </a:r>
@@ -14409,8 +14409,8 @@
                 <a:solidFill>
                   <a:srgbClr val="414242"/>
                 </a:solidFill>
-                <a:latin typeface="Aptos"/>
-                <a:ea typeface="Yu Gothic"/>
+                <a:latin typeface="Noto Sans JP"/>
+                <a:ea typeface="Noto Sans JP"/>
               </a:rPr>
               <a:t>提案上の使い方</a:t>
             </a:r>
@@ -14475,8 +14475,8 @@
                 <a:solidFill>
                   <a:srgbClr val="414242"/>
                 </a:solidFill>
-                <a:latin typeface="Aptos"/>
-                <a:ea typeface="Yu Gothic"/>
+                <a:latin typeface="Noto Sans JP"/>
+                <a:ea typeface="Noto Sans JP"/>
               </a:rPr>
               <a:t>kintone本体</a:t>
             </a:r>
@@ -14541,8 +14541,8 @@
                 <a:solidFill>
                   <a:srgbClr val="6D7375"/>
                 </a:solidFill>
-                <a:latin typeface="Aptos"/>
-                <a:ea typeface="Yu Gothic"/>
+                <a:latin typeface="Noto Sans JP"/>
+                <a:ea typeface="Noto Sans JP"/>
               </a:rPr>
               <a:t>ライト 1,000円 / ID / 月</a:t>
             </a:r>
@@ -14554,8 +14554,8 @@
                 <a:solidFill>
                   <a:srgbClr val="6D7375"/>
                 </a:solidFill>
-                <a:latin typeface="Aptos"/>
-                <a:ea typeface="Yu Gothic"/>
+                <a:latin typeface="Noto Sans JP"/>
+                <a:ea typeface="Noto Sans JP"/>
               </a:rPr>
               <a:t>スタンダード 1,800円 / ID / 月</a:t>
             </a:r>
@@ -14567,8 +14567,8 @@
                 <a:solidFill>
                   <a:srgbClr val="6D7375"/>
                 </a:solidFill>
-                <a:latin typeface="Aptos"/>
-                <a:ea typeface="Yu Gothic"/>
+                <a:latin typeface="Noto Sans JP"/>
+                <a:ea typeface="Noto Sans JP"/>
               </a:rPr>
               <a:t>ワイド 3,000円 / ID / 月</a:t>
             </a:r>
@@ -14633,8 +14633,8 @@
                 <a:solidFill>
                   <a:srgbClr val="6D7375"/>
                 </a:solidFill>
-                <a:latin typeface="Aptos"/>
-                <a:ea typeface="Yu Gothic"/>
+                <a:latin typeface="Noto Sans JP"/>
+                <a:ea typeface="Noto Sans JP"/>
               </a:rPr>
               <a:t>1IDあたり1000円台の印象</a:t>
             </a:r>
@@ -14699,8 +14699,8 @@
                 <a:solidFill>
                   <a:srgbClr val="6D7375"/>
                 </a:solidFill>
-                <a:latin typeface="Aptos"/>
-                <a:ea typeface="Yu Gothic"/>
+                <a:latin typeface="Noto Sans JP"/>
+                <a:ea typeface="Noto Sans JP"/>
               </a:rPr>
               <a:t>Log Liteと初年度Packで初見の価格差を縮める。</a:t>
             </a:r>
@@ -14765,8 +14765,8 @@
                 <a:solidFill>
                   <a:srgbClr val="414242"/>
                 </a:solidFill>
-                <a:latin typeface="Aptos"/>
-                <a:ea typeface="Yu Gothic"/>
+                <a:latin typeface="Noto Sans JP"/>
+                <a:ea typeface="Noto Sans JP"/>
               </a:rPr>
               <a:t>kintone連携サービス</a:t>
             </a:r>
@@ -14831,8 +14831,8 @@
                 <a:solidFill>
                   <a:srgbClr val="6D7375"/>
                 </a:solidFill>
-                <a:latin typeface="Aptos"/>
-                <a:ea typeface="Yu Gothic"/>
+                <a:latin typeface="Noto Sans JP"/>
+                <a:ea typeface="Noto Sans JP"/>
               </a:rPr>
               <a:t>Toyokumo PrintCreator</a:t>
             </a:r>
@@ -14844,8 +14844,8 @@
                 <a:solidFill>
                   <a:srgbClr val="6D7375"/>
                 </a:solidFill>
-                <a:latin typeface="Aptos"/>
-                <a:ea typeface="Yu Gothic"/>
+                <a:latin typeface="Noto Sans JP"/>
+                <a:ea typeface="Noto Sans JP"/>
               </a:rPr>
               <a:t>M-SOLUTIONS Smart at AI</a:t>
             </a:r>
@@ -14910,8 +14910,8 @@
                 <a:solidFill>
                   <a:srgbClr val="6D7375"/>
                 </a:solidFill>
-                <a:latin typeface="Aptos"/>
-                <a:ea typeface="Yu Gothic"/>
+                <a:latin typeface="Noto Sans JP"/>
+                <a:ea typeface="Noto Sans JP"/>
               </a:rPr>
               <a:t>ID単価よりもパック・支援込みで比較</a:t>
             </a:r>
@@ -14976,8 +14976,8 @@
                 <a:solidFill>
                   <a:srgbClr val="6D7375"/>
                 </a:solidFill>
-                <a:latin typeface="Aptos"/>
-                <a:ea typeface="Yu Gothic"/>
+                <a:latin typeface="Noto Sans JP"/>
+                <a:ea typeface="Noto Sans JP"/>
               </a:rPr>
               <a:t>kintoneにデータを残す価値をPackで説明する。</a:t>
             </a:r>
@@ -15042,8 +15042,8 @@
                 <a:solidFill>
                   <a:srgbClr val="414242"/>
                 </a:solidFill>
-                <a:latin typeface="Aptos"/>
-                <a:ea typeface="Yu Gothic"/>
+                <a:latin typeface="Noto Sans JP"/>
+                <a:ea typeface="Noto Sans JP"/>
               </a:rPr>
               <a:t>AI議事録</a:t>
             </a:r>
@@ -15108,8 +15108,8 @@
                 <a:solidFill>
                   <a:srgbClr val="6D7375"/>
                 </a:solidFill>
-                <a:latin typeface="Aptos"/>
-                <a:ea typeface="Yu Gothic"/>
+                <a:latin typeface="Noto Sans JP"/>
+                <a:ea typeface="Noto Sans JP"/>
               </a:rPr>
               <a:t>Notta / Rimo / AI議事録取れる君</a:t>
             </a:r>
@@ -15121,8 +15121,8 @@
                 <a:solidFill>
                   <a:srgbClr val="6D7375"/>
                 </a:solidFill>
-                <a:latin typeface="Aptos"/>
-                <a:ea typeface="Yu Gothic"/>
+                <a:latin typeface="Noto Sans JP"/>
+                <a:ea typeface="Noto Sans JP"/>
               </a:rPr>
               <a:t>LINE WORKS AiNote</a:t>
             </a:r>
@@ -15187,8 +15187,8 @@
                 <a:solidFill>
                   <a:srgbClr val="6D7375"/>
                 </a:solidFill>
-                <a:latin typeface="Aptos"/>
-                <a:ea typeface="Yu Gothic"/>
+                <a:latin typeface="Noto Sans JP"/>
+                <a:ea typeface="Noto Sans JP"/>
               </a:rPr>
               <a:t>議事録単体に見えると、5,980円 / IDは高く見える。</a:t>
             </a:r>
@@ -15253,8 +15253,8 @@
                 <a:solidFill>
                   <a:srgbClr val="6D7375"/>
                 </a:solidFill>
-                <a:latin typeface="Aptos"/>
-                <a:ea typeface="Yu Gothic"/>
+                <a:latin typeface="Noto Sans JP"/>
+                <a:ea typeface="Noto Sans JP"/>
               </a:rPr>
               <a:t>初年度限定2,980円/IDを価格アンカーにし、議事録ではなく顧客接点データ化として売る。</a:t>
             </a:r>
@@ -15346,8 +15346,8 @@
                 <a:solidFill>
                   <a:srgbClr val="6D7375"/>
                 </a:solidFill>
-                <a:latin typeface="Aptos"/>
-                <a:ea typeface="Yu Gothic"/>
+                <a:latin typeface="Noto Sans JP"/>
+                <a:ea typeface="Noto Sans JP"/>
               </a:rPr>
               <a:t>Competitive Comparison</a:t>
             </a:r>
@@ -15383,8 +15383,8 @@
                 <a:solidFill>
                   <a:srgbClr val="414242"/>
                 </a:solidFill>
-                <a:latin typeface="Aptos"/>
-                <a:ea typeface="Yu Gothic"/>
+                <a:latin typeface="Noto Sans JP"/>
+                <a:ea typeface="Noto Sans JP"/>
               </a:rPr>
               <a:t>FrontAgent</a:t>
             </a:r>
@@ -15420,8 +15420,8 @@
                 <a:solidFill>
                   <a:srgbClr val="414242"/>
                 </a:solidFill>
-                <a:latin typeface="Aptos"/>
-                <a:ea typeface="Yu Gothic"/>
+                <a:latin typeface="Noto Sans JP"/>
+                <a:ea typeface="Noto Sans JP"/>
               </a:rPr>
               <a:t>比較される相手は、3カテゴリに分かれる</a:t>
             </a:r>
@@ -15515,8 +15515,8 @@
                 <a:solidFill>
                   <a:srgbClr val="6D7375"/>
                 </a:solidFill>
-                <a:latin typeface="Aptos"/>
-                <a:ea typeface="Yu Gothic"/>
+                <a:latin typeface="Noto Sans JP"/>
+                <a:ea typeface="Noto Sans JP"/>
               </a:rPr>
               <a:t>他社比較は、価格ではなく売り方の設計に使う</a:t>
             </a:r>
@@ -15552,8 +15552,8 @@
                 <a:solidFill>
                   <a:srgbClr val="6D7375"/>
                 </a:solidFill>
-                <a:latin typeface="Aptos"/>
-                <a:ea typeface="Yu Gothic"/>
+                <a:latin typeface="Noto Sans JP"/>
+                <a:ea typeface="Noto Sans JP"/>
               </a:rPr>
               <a:t>09</a:t>
             </a:r>
@@ -15593,7 +15593,7 @@
                 <a:solidFill>
                   <a:srgbClr val="FF7143"/>
                 </a:solidFill>
-                <a:ea typeface="Yu Gothic"/>
+                <a:ea typeface="Noto Sans JP"/>
               </a:rPr>
               <a:t/>
             </a:r>
@@ -15651,13 +15651,13 @@
     </a:clrScheme>
     <a:fontScheme name="Office">
       <a:majorFont>
-        <a:latin typeface="Aptos Display"/>
-        <a:ea typeface="Yu Gothic"/>
+        <a:latin typeface="Noto Sans JP"/>
+        <a:ea typeface="Noto Sans JP"/>
         <a:cs typeface=""/>
       </a:majorFont>
       <a:minorFont>
-        <a:latin typeface="Aptos"/>
-        <a:ea typeface="Yu Gothic"/>
+        <a:latin typeface="Noto Sans JP"/>
+        <a:ea typeface="Noto Sans JP"/>
         <a:cs typeface=""/>
       </a:minorFont>
     </a:fontScheme>

</xml_diff>

<commit_message>
docs: add tax exclusive umee kintone price variants
</commit_message>
<xml_diff>
--- a/deck-system/decks/umee-sbcs-kintone-plan/exports/umee-sbcs-kintone-plan-editable.pptx
+++ b/deck-system/decks/umee-sbcs-kintone-plan/exports/umee-sbcs-kintone-plan-editable.pptx
@@ -4257,7 +4257,7 @@
                 <a:latin typeface="Noto Sans JP"/>
                 <a:ea typeface="Noto Sans JP"/>
               </a:rPr>
-              <a:t>1ID限定 / 980円</a:t>
+              <a:t>1ID限定 / 980円（税抜）</a:t>
             </a:r>
           </a:p>
           <a:p>
@@ -4413,7 +4413,7 @@
                 <a:latin typeface="Noto Sans JP"/>
                 <a:ea typeface="Noto Sans JP"/>
               </a:rPr>
-              <a:t>初年度限定 2,980円 / ID</a:t>
+              <a:t>初年度限定 2,980円 / ID（税抜）</a:t>
             </a:r>
           </a:p>
           <a:p>
@@ -4598,7 +4598,7 @@
                 <a:latin typeface="Noto Sans JP"/>
                 <a:ea typeface="Noto Sans JP"/>
               </a:rPr>
-              <a:t>1ID限定・980円/月の見せ球。追加IDは不可。月1,800分・1ログ5時間・AI要約100回までにする。</a:t>
+              <a:t>1ID限定・980円/月（税抜）の見せ球。追加IDは不可。月1,800分・1ログ5時間・AI要約100回までにする。</a:t>
             </a:r>
           </a:p>
         </p:txBody>
@@ -4741,7 +4741,7 @@
                 <a:latin typeface="Noto Sans JP"/>
                 <a:ea typeface="Noto Sans JP"/>
               </a:rPr>
-              <a:t>2ID以上・追加ID・kintone連携を受ける本命プラン。2,980円は初年度のみ、2年目以降は通常単価。</a:t>
+              <a:t>2ID以上・追加ID・kintone連携を受ける本命プラン。2,980円（税抜）は初年度のみ、2年目以降は通常単価。</a:t>
             </a:r>
           </a:p>
         </p:txBody>
@@ -6390,7 +6390,7 @@
                 <a:latin typeface="Noto Sans JP"/>
                 <a:ea typeface="Noto Sans JP"/>
               </a:rPr>
-              <a:t>Log Liteは1ID限定 980円/月。Notta Premium基準の上限で、比較時の価格アンカーにする。</a:t>
+              <a:t>Log Liteは1ID限定 980円/月（税抜）。Notta Premium基準の上限で、比較時の価格アンカーにする。</a:t>
             </a:r>
           </a:p>
         </p:txBody>
@@ -7565,7 +7565,7 @@
                 <a:latin typeface="Noto Sans JP"/>
                 <a:ea typeface="Noto Sans JP"/>
               </a:rPr>
-              <a:t>980円 / 1ID / 月</a:t>
+              <a:t>980円 / 1ID / 月（税抜）</a:t>
             </a:r>
           </a:p>
         </p:txBody>
@@ -7868,7 +7868,7 @@
                 <a:latin typeface="Noto Sans JP"/>
                 <a:ea typeface="Noto Sans JP"/>
               </a:rPr>
-              <a:t>通常5,980円 / ID / 月</a:t>
+              <a:t>通常5,980円 / ID / 月（税抜）</a:t>
             </a:r>
           </a:p>
         </p:txBody>
@@ -8000,7 +8000,7 @@
                 <a:latin typeface="Noto Sans JP"/>
                 <a:ea typeface="Noto Sans JP"/>
               </a:rPr>
-              <a:t>12ヶ月契約。2,980円/ID/月は初年度のみ。（LogLiteからの移管は対象外）</a:t>
+              <a:t>12ヶ月契約。2,980円/ID/月（税抜）は初年度のみ。（LogLiteからの移管は対象外）</a:t>
             </a:r>
           </a:p>
         </p:txBody>
@@ -8470,7 +8470,7 @@
                 <a:latin typeface="Noto Sans JP"/>
                 <a:ea typeface="Noto Sans JP"/>
               </a:rPr>
-              <a:t>1ID限定 980円/月</a:t>
+              <a:t>1ID限定 980円/月（税抜）</a:t>
             </a:r>
           </a:p>
         </p:txBody>
@@ -9039,7 +9039,7 @@
                 <a:latin typeface="Noto Sans JP"/>
                 <a:ea typeface="Noto Sans JP"/>
               </a:rPr>
-              <a:t>1ID限定 / 980円 / 月</a:t>
+              <a:t>1ID限定 / 980円 / 月（税抜）</a:t>
             </a:r>
           </a:p>
         </p:txBody>
@@ -10104,7 +10104,7 @@
                 <a:latin typeface="Noto Sans JP"/>
                 <a:ea typeface="Noto Sans JP"/>
               </a:rPr>
-              <a:t>初年度限定</a:t>
+              <a:t>初年度限定（税抜）</a:t>
             </a:r>
           </a:p>
         </p:txBody>
@@ -10141,7 +10141,7 @@
                 <a:latin typeface="Noto Sans JP"/>
                 <a:ea typeface="Noto Sans JP"/>
               </a:rPr>
-              <a:t>2,980円/ID/月</a:t>
+              <a:t>2,980円/ID/月（税抜）</a:t>
             </a:r>
           </a:p>
         </p:txBody>
@@ -10405,7 +10405,7 @@
                 <a:latin typeface="Noto Sans JP"/>
                 <a:ea typeface="Noto Sans JP"/>
               </a:rPr>
-              <a:t>2年目以降 通常5,980円/ID/月</a:t>
+              <a:t>2年目以降 通常5,980円/ID/月（税抜）</a:t>
             </a:r>
           </a:p>
         </p:txBody>
@@ -10537,7 +10537,7 @@
                 <a:latin typeface="Noto Sans JP"/>
                 <a:ea typeface="Noto Sans JP"/>
               </a:rPr>
-              <a:t>通常</a:t>
+              <a:t>通常（税抜）</a:t>
             </a:r>
           </a:p>
         </p:txBody>
@@ -10603,7 +10603,7 @@
                 <a:latin typeface="Noto Sans JP"/>
                 <a:ea typeface="Noto Sans JP"/>
               </a:rPr>
-              <a:t>初年度限定</a:t>
+              <a:t>初年度限定（税抜）</a:t>
             </a:r>
           </a:p>
         </p:txBody>
@@ -10735,7 +10735,7 @@
                 <a:latin typeface="Noto Sans JP"/>
                 <a:ea typeface="Noto Sans JP"/>
               </a:rPr>
-              <a:t>5,980円 / ID / 月</a:t>
+              <a:t>5,980円 / ID / 月（税抜）</a:t>
             </a:r>
           </a:p>
         </p:txBody>
@@ -10801,7 +10801,7 @@
                 <a:latin typeface="Noto Sans JP"/>
                 <a:ea typeface="Noto Sans JP"/>
               </a:rPr>
-              <a:t>2,980円 / ID / 月</a:t>
+              <a:t>2,980円 / ID / 月（税抜）</a:t>
             </a:r>
           </a:p>
         </p:txBody>
@@ -12089,7 +12089,7 @@
                 <a:latin typeface="Noto Sans JP"/>
                 <a:ea typeface="Noto Sans JP"/>
               </a:rPr>
-              <a:t>通常月額</a:t>
+              <a:t>通常月額（税抜）</a:t>
             </a:r>
           </a:p>
         </p:txBody>
@@ -12155,7 +12155,7 @@
                 <a:latin typeface="Noto Sans JP"/>
                 <a:ea typeface="Noto Sans JP"/>
               </a:rPr>
-              <a:t>初年度限定月額</a:t>
+              <a:t>初年度限定月額（税抜）</a:t>
             </a:r>
           </a:p>
         </p:txBody>
@@ -14046,7 +14046,7 @@
                 <a:latin typeface="Noto Sans JP"/>
                 <a:ea typeface="Noto Sans JP"/>
               </a:rPr>
-              <a:t>初年度のみ2,980円/ID。2年目以降は通常5,980円/ID</a:t>
+              <a:t>初年度のみ2,980円/ID（税抜）。2年目以降は通常5,980円/ID（税抜）</a:t>
             </a:r>
           </a:p>
         </p:txBody>
@@ -15190,7 +15190,7 @@
                 <a:latin typeface="Noto Sans JP"/>
                 <a:ea typeface="Noto Sans JP"/>
               </a:rPr>
-              <a:t>議事録単体に見えると、5,980円 / IDは高く見える。</a:t>
+              <a:t>議事録単体に見えると、5,980円 / ID（税抜）は高く見える。</a:t>
             </a:r>
           </a:p>
         </p:txBody>
@@ -15256,7 +15256,7 @@
                 <a:latin typeface="Noto Sans JP"/>
                 <a:ea typeface="Noto Sans JP"/>
               </a:rPr>
-              <a:t>初年度限定2,980円/IDを価格アンカーにし、議事録ではなく顧客接点データ化として売る。</a:t>
+              <a:t>初年度限定2,980円/ID（税抜）を価格アンカーにし、議事録ではなく顧客接点データ化として売る。</a:t>
             </a:r>
           </a:p>
         </p:txBody>

</xml_diff>